<commit_message>
Refresh speaker materials and add Aimbition to slides
</commit_message>
<xml_diff>
--- a/output/pptx/sdlcai-2026-intro.pptx
+++ b/output/pptx/sdlcai-2026-intro.pptx
@@ -2,24 +2,24 @@
 <file path=ppt/presentation.xml><?xml version="1.0" encoding="utf-8"?>
 <p:presentation xmlns:p="http://schemas.openxmlformats.org/presentationml/2006/main" embedTrueTypeFonts="1" saveSubsetFonts="0">
   <p:sldMasterIdLst>
-    <p:sldMasterId xmlns:r="http://schemas.openxmlformats.org/officeDocument/2006/relationships" id="2147483648" r:id="R68a210fddf5d49f2"/>
+    <p:sldMasterId xmlns:r="http://schemas.openxmlformats.org/officeDocument/2006/relationships" id="2147483648" r:id="R489274cb739f4c3f"/>
   </p:sldMasterIdLst>
   <p:notesMasterIdLst>
-    <p:notesMasterId xmlns:r="http://schemas.openxmlformats.org/officeDocument/2006/relationships" r:id="Rccdccbc7a89e4f77"/>
+    <p:notesMasterId xmlns:r="http://schemas.openxmlformats.org/officeDocument/2006/relationships" r:id="R828a339dcd3647a8"/>
   </p:notesMasterIdLst>
   <p:sldIdLst>
-    <p:sldId xmlns:r="http://schemas.openxmlformats.org/officeDocument/2006/relationships" id="256" r:id="R45abfa7e67ab4af5"/>
-    <p:sldId xmlns:r="http://schemas.openxmlformats.org/officeDocument/2006/relationships" id="257" r:id="R5108edaad3664c86"/>
-    <p:sldId xmlns:r="http://schemas.openxmlformats.org/officeDocument/2006/relationships" id="258" r:id="R7a42b1b4ff654842"/>
-    <p:sldId xmlns:r="http://schemas.openxmlformats.org/officeDocument/2006/relationships" id="259" r:id="R68ffd70ff7f94e33"/>
-    <p:sldId xmlns:r="http://schemas.openxmlformats.org/officeDocument/2006/relationships" id="260" r:id="R88c42ce47cef4409"/>
-    <p:sldId xmlns:r="http://schemas.openxmlformats.org/officeDocument/2006/relationships" id="261" r:id="Raededaf842b141ec"/>
-    <p:sldId xmlns:r="http://schemas.openxmlformats.org/officeDocument/2006/relationships" id="262" r:id="R92215e42f6224d57"/>
-    <p:sldId xmlns:r="http://schemas.openxmlformats.org/officeDocument/2006/relationships" id="263" r:id="R36c418496a0047d4"/>
-    <p:sldId xmlns:r="http://schemas.openxmlformats.org/officeDocument/2006/relationships" id="264" r:id="Rae9b1e85b5d64c43"/>
-    <p:sldId xmlns:r="http://schemas.openxmlformats.org/officeDocument/2006/relationships" id="265" r:id="Rac5511f0edac426e"/>
-    <p:sldId xmlns:r="http://schemas.openxmlformats.org/officeDocument/2006/relationships" id="266" r:id="Rc28011f5bba64c31"/>
-    <p:sldId xmlns:r="http://schemas.openxmlformats.org/officeDocument/2006/relationships" id="267" r:id="R1004ae04482b47e0"/>
+    <p:sldId xmlns:r="http://schemas.openxmlformats.org/officeDocument/2006/relationships" id="256" r:id="R48c165477dfc4a50"/>
+    <p:sldId xmlns:r="http://schemas.openxmlformats.org/officeDocument/2006/relationships" id="257" r:id="Rcbfbd52c1d1c4e60"/>
+    <p:sldId xmlns:r="http://schemas.openxmlformats.org/officeDocument/2006/relationships" id="258" r:id="Raf5655c8cd30492a"/>
+    <p:sldId xmlns:r="http://schemas.openxmlformats.org/officeDocument/2006/relationships" id="259" r:id="R9343a7518d8c4179"/>
+    <p:sldId xmlns:r="http://schemas.openxmlformats.org/officeDocument/2006/relationships" id="260" r:id="Rbff3fceeed6a4b31"/>
+    <p:sldId xmlns:r="http://schemas.openxmlformats.org/officeDocument/2006/relationships" id="261" r:id="Raf1f164367b24f54"/>
+    <p:sldId xmlns:r="http://schemas.openxmlformats.org/officeDocument/2006/relationships" id="262" r:id="R65d64a35ecc34a33"/>
+    <p:sldId xmlns:r="http://schemas.openxmlformats.org/officeDocument/2006/relationships" id="263" r:id="R7a3d857d8f094a0e"/>
+    <p:sldId xmlns:r="http://schemas.openxmlformats.org/officeDocument/2006/relationships" id="264" r:id="R9a2753be369f447c"/>
+    <p:sldId xmlns:r="http://schemas.openxmlformats.org/officeDocument/2006/relationships" id="265" r:id="R401223f9b9334292"/>
+    <p:sldId xmlns:r="http://schemas.openxmlformats.org/officeDocument/2006/relationships" id="266" r:id="R0e204df28df048bf"/>
+    <p:sldId xmlns:r="http://schemas.openxmlformats.org/officeDocument/2006/relationships" id="267" r:id="R9d406194ddb6406c"/>
   </p:sldIdLst>
   <p:sldSz cx="18288000" cy="10287000"/>
   <p:notesSz cx="6858000" cy="9144000"/>
@@ -1466,7 +1466,7 @@
           <p:cNvPr id="3" name="Title">
             <a:extLst xmlns:a="http://schemas.openxmlformats.org/drawingml/2006/main">
               <a:ext uri="{FF2B5EF4-FFF2-40B4-BE49-F238E27FC236}">
-                <a16:creationId xmlns:a16="http://schemas.microsoft.com/office/drawing/2014/main" id="{9138B2B2-D89B-4205-9E0D-5C37945AFF35}"/>
+                <a16:creationId xmlns:a16="http://schemas.microsoft.com/office/drawing/2014/main" id="{B91E114F-8242-4BF1-B85B-733D8C63A898}"/>
               </a:ext>
             </a:extLst>
           </p:cNvPr>
@@ -1623,7 +1623,7 @@
           <p:cNvPr id="2" name="Subtitle">
             <a:extLst xmlns:a="http://schemas.openxmlformats.org/drawingml/2006/main">
               <a:ext uri="{FF2B5EF4-FFF2-40B4-BE49-F238E27FC236}">
-                <a16:creationId xmlns:a16="http://schemas.microsoft.com/office/drawing/2014/main" id="{4F306B62-08AC-406D-84D6-0F045FBAF7FD}"/>
+                <a16:creationId xmlns:a16="http://schemas.microsoft.com/office/drawing/2014/main" id="{C3F9000B-BC70-4206-B91D-B12AE19F09A1}"/>
               </a:ext>
             </a:extLst>
           </p:cNvPr>
@@ -1797,7 +1797,7 @@
           <p:cNvPr id="2" name="Section title">
             <a:extLst xmlns:a="http://schemas.openxmlformats.org/drawingml/2006/main">
               <a:ext uri="{FF2B5EF4-FFF2-40B4-BE49-F238E27FC236}">
-                <a16:creationId xmlns:a16="http://schemas.microsoft.com/office/drawing/2014/main" id="{219F7918-BD9B-4213-916D-1048FF77FEBE}"/>
+                <a16:creationId xmlns:a16="http://schemas.microsoft.com/office/drawing/2014/main" id="{BF8613D4-E12B-40AB-9C4A-2EC87288A1C3}"/>
               </a:ext>
             </a:extLst>
           </p:cNvPr>
@@ -1971,7 +1971,7 @@
           <p:cNvPr id="3" name="Title">
             <a:extLst xmlns:a="http://schemas.openxmlformats.org/drawingml/2006/main">
               <a:ext uri="{FF2B5EF4-FFF2-40B4-BE49-F238E27FC236}">
-                <a16:creationId xmlns:a16="http://schemas.microsoft.com/office/drawing/2014/main" id="{E7EB87DB-AE31-4E0F-8976-0C263B5CDC72}"/>
+                <a16:creationId xmlns:a16="http://schemas.microsoft.com/office/drawing/2014/main" id="{81F6B6BE-6EA7-4F5B-B15A-45FF3FD6B193}"/>
               </a:ext>
             </a:extLst>
           </p:cNvPr>
@@ -2128,7 +2128,7 @@
           <p:cNvPr id="2" name="Body">
             <a:extLst xmlns:a="http://schemas.openxmlformats.org/drawingml/2006/main">
               <a:ext uri="{FF2B5EF4-FFF2-40B4-BE49-F238E27FC236}">
-                <a16:creationId xmlns:a16="http://schemas.microsoft.com/office/drawing/2014/main" id="{3E8D00E5-8136-4C48-91D6-FCDED1BD2FEB}"/>
+                <a16:creationId xmlns:a16="http://schemas.microsoft.com/office/drawing/2014/main" id="{19EFA6B0-253E-4776-BF5E-A0CAC462FDAE}"/>
               </a:ext>
             </a:extLst>
           </p:cNvPr>
@@ -2302,7 +2302,7 @@
           <p:cNvPr id="4" name="Title">
             <a:extLst xmlns:a="http://schemas.openxmlformats.org/drawingml/2006/main">
               <a:ext uri="{FF2B5EF4-FFF2-40B4-BE49-F238E27FC236}">
-                <a16:creationId xmlns:a16="http://schemas.microsoft.com/office/drawing/2014/main" id="{28BADA78-8DA5-4184-8F8D-E52D31A49FEB}"/>
+                <a16:creationId xmlns:a16="http://schemas.microsoft.com/office/drawing/2014/main" id="{2E6F3D1A-7E7A-4118-8800-D0B3DB084225}"/>
               </a:ext>
             </a:extLst>
           </p:cNvPr>
@@ -2459,7 +2459,7 @@
           <p:cNvPr id="2" name="Left column">
             <a:extLst xmlns:a="http://schemas.openxmlformats.org/drawingml/2006/main">
               <a:ext uri="{FF2B5EF4-FFF2-40B4-BE49-F238E27FC236}">
-                <a16:creationId xmlns:a16="http://schemas.microsoft.com/office/drawing/2014/main" id="{D5813791-1B39-474D-A729-CFBBED350F77}"/>
+                <a16:creationId xmlns:a16="http://schemas.microsoft.com/office/drawing/2014/main" id="{F08E51A3-467B-4D80-8668-8B409DFE9926}"/>
               </a:ext>
             </a:extLst>
           </p:cNvPr>
@@ -2616,7 +2616,7 @@
           <p:cNvPr id="3" name="Right column">
             <a:extLst xmlns:a="http://schemas.openxmlformats.org/drawingml/2006/main">
               <a:ext uri="{FF2B5EF4-FFF2-40B4-BE49-F238E27FC236}">
-                <a16:creationId xmlns:a16="http://schemas.microsoft.com/office/drawing/2014/main" id="{8221697C-27FD-4AAF-B951-064F66DE7338}"/>
+                <a16:creationId xmlns:a16="http://schemas.microsoft.com/office/drawing/2014/main" id="{E5FA6CCF-D05A-4AF2-ADF9-C0DA0AA928E5}"/>
               </a:ext>
             </a:extLst>
           </p:cNvPr>
@@ -2790,7 +2790,7 @@
           <p:cNvPr id="3" name="Title">
             <a:extLst xmlns:a="http://schemas.openxmlformats.org/drawingml/2006/main">
               <a:ext uri="{FF2B5EF4-FFF2-40B4-BE49-F238E27FC236}">
-                <a16:creationId xmlns:a16="http://schemas.microsoft.com/office/drawing/2014/main" id="{42668C4C-14B7-4C13-BA00-B2419663C543}"/>
+                <a16:creationId xmlns:a16="http://schemas.microsoft.com/office/drawing/2014/main" id="{38AE30B3-A5F0-45A9-AC90-21C7C7B76133}"/>
               </a:ext>
             </a:extLst>
           </p:cNvPr>
@@ -2947,7 +2947,7 @@
           <p:cNvPr id="2" name="Left column">
             <a:extLst xmlns:a="http://schemas.openxmlformats.org/drawingml/2006/main">
               <a:ext uri="{FF2B5EF4-FFF2-40B4-BE49-F238E27FC236}">
-                <a16:creationId xmlns:a16="http://schemas.microsoft.com/office/drawing/2014/main" id="{AAED25E9-40FF-41BD-99FD-584B266AB729}"/>
+                <a16:creationId xmlns:a16="http://schemas.microsoft.com/office/drawing/2014/main" id="{4BDF6F59-8EC3-4BFD-A18D-4FB4B0E662FB}"/>
               </a:ext>
             </a:extLst>
           </p:cNvPr>
@@ -3142,12 +3142,12 @@
   </p:cSld>
   <p:clrMap bg1="lt1" tx1="dk1" bg2="lt2" tx2="dk2" accent1="accent1" accent2="accent2" accent3="accent3" accent4="accent4" accent5="accent5" accent6="accent6" hlink="hlink" folHlink="folHlink"/>
   <p:sldLayoutIdLst>
-    <p:sldLayoutId xmlns:r="http://schemas.openxmlformats.org/officeDocument/2006/relationships" id="2147483649" r:id="R7b3ef272d48e4c9b"/>
-    <p:sldLayoutId xmlns:r="http://schemas.openxmlformats.org/officeDocument/2006/relationships" id="2147483650" r:id="R2edc7a89f64d4fd1"/>
-    <p:sldLayoutId xmlns:r="http://schemas.openxmlformats.org/officeDocument/2006/relationships" id="2147483651" r:id="R24d4a832fe794b5c"/>
-    <p:sldLayoutId xmlns:r="http://schemas.openxmlformats.org/officeDocument/2006/relationships" id="2147483652" r:id="Ra08b9908c382457b"/>
-    <p:sldLayoutId xmlns:r="http://schemas.openxmlformats.org/officeDocument/2006/relationships" id="2147483653" r:id="R5fa76a2e545b4c96"/>
-    <p:sldLayoutId xmlns:r="http://schemas.openxmlformats.org/officeDocument/2006/relationships" id="2147483654" r:id="R8c474d3063cf4564"/>
+    <p:sldLayoutId xmlns:r="http://schemas.openxmlformats.org/officeDocument/2006/relationships" id="2147483649" r:id="Rb0c1524e52a74fc9"/>
+    <p:sldLayoutId xmlns:r="http://schemas.openxmlformats.org/officeDocument/2006/relationships" id="2147483650" r:id="R4765d806d77e49a0"/>
+    <p:sldLayoutId xmlns:r="http://schemas.openxmlformats.org/officeDocument/2006/relationships" id="2147483651" r:id="R3d2684d56cda484d"/>
+    <p:sldLayoutId xmlns:r="http://schemas.openxmlformats.org/officeDocument/2006/relationships" id="2147483652" r:id="R3efe2d2e152c46bb"/>
+    <p:sldLayoutId xmlns:r="http://schemas.openxmlformats.org/officeDocument/2006/relationships" id="2147483653" r:id="Ra140a05cfe564146"/>
+    <p:sldLayoutId xmlns:r="http://schemas.openxmlformats.org/officeDocument/2006/relationships" id="2147483654" r:id="R386f5be033f544a0"/>
   </p:sldLayoutIdLst>
   <p:txStyles>
     <p:titleStyle>
@@ -3698,7 +3698,7 @@
           <p:cNvPr id="10" name="">
             <a:extLst xmlns:a="http://schemas.openxmlformats.org/drawingml/2006/main">
               <a:ext uri="{FF2B5EF4-FFF2-40B4-BE49-F238E27FC236}">
-                <a16:creationId xmlns:a16="http://schemas.microsoft.com/office/drawing/2014/main" id="{72CEDA14-417F-4B44-BE44-953774B7DD84}"/>
+                <a16:creationId xmlns:a16="http://schemas.microsoft.com/office/drawing/2014/main" id="{2A92ACA9-D112-4C4D-AA62-EAE729199E12}"/>
               </a:ext>
             </a:extLst>
           </p:cNvPr>
@@ -3708,7 +3708,7 @@
           <p:nvPr/>
         </p:nvPicPr>
         <p:blipFill>
-          <a:blip xmlns:r="http://schemas.openxmlformats.org/officeDocument/2006/relationships" xmlns:a="http://schemas.openxmlformats.org/drawingml/2006/main" r:embed="Rd16f315a093d485e"/>
+          <a:blip xmlns:r="http://schemas.openxmlformats.org/officeDocument/2006/relationships" xmlns:a="http://schemas.openxmlformats.org/drawingml/2006/main" r:embed="R00128ba64b0240ce"/>
           <a:stretch xmlns:a="http://schemas.openxmlformats.org/drawingml/2006/main"/>
         </p:blipFill>
         <p:spPr>
@@ -3726,7 +3726,7 @@
           <p:cNvPr id="2" name="welcome-span-1">
             <a:extLst xmlns:a="http://schemas.openxmlformats.org/drawingml/2006/main">
               <a:ext uri="{FF2B5EF4-FFF2-40B4-BE49-F238E27FC236}">
-                <a16:creationId xmlns:a16="http://schemas.microsoft.com/office/drawing/2014/main" id="{D6775796-7038-4185-9A32-B6C88F9B8E76}"/>
+                <a16:creationId xmlns:a16="http://schemas.microsoft.com/office/drawing/2014/main" id="{8E7B593E-CA59-4038-9D96-524875290563}"/>
               </a:ext>
             </a:extLst>
           </p:cNvPr>
@@ -3794,7 +3794,7 @@
           <p:cNvPr id="3" name="welcome-span-2">
             <a:extLst xmlns:a="http://schemas.openxmlformats.org/drawingml/2006/main">
               <a:ext uri="{FF2B5EF4-FFF2-40B4-BE49-F238E27FC236}">
-                <a16:creationId xmlns:a16="http://schemas.microsoft.com/office/drawing/2014/main" id="{04CEFD65-2D7E-4749-B19F-8CD9A2826BD8}"/>
+                <a16:creationId xmlns:a16="http://schemas.microsoft.com/office/drawing/2014/main" id="{EB473E38-D39D-4F81-8045-5D9347789A29}"/>
               </a:ext>
             </a:extLst>
           </p:cNvPr>
@@ -3862,7 +3862,7 @@
           <p:cNvPr id="4" name="welcome-p-3">
             <a:extLst xmlns:a="http://schemas.openxmlformats.org/drawingml/2006/main">
               <a:ext uri="{FF2B5EF4-FFF2-40B4-BE49-F238E27FC236}">
-                <a16:creationId xmlns:a16="http://schemas.microsoft.com/office/drawing/2014/main" id="{DF8196BE-A3BA-4CC0-AA28-719B7B5C8BD1}"/>
+                <a16:creationId xmlns:a16="http://schemas.microsoft.com/office/drawing/2014/main" id="{36E44517-5527-4039-95E4-3CA469DC9C0E}"/>
               </a:ext>
             </a:extLst>
           </p:cNvPr>
@@ -3930,7 +3930,7 @@
           <p:cNvPr id="5" name="welcome-h1-4">
             <a:extLst xmlns:a="http://schemas.openxmlformats.org/drawingml/2006/main">
               <a:ext uri="{FF2B5EF4-FFF2-40B4-BE49-F238E27FC236}">
-                <a16:creationId xmlns:a16="http://schemas.microsoft.com/office/drawing/2014/main" id="{B203EB2D-6DCA-4722-9777-6D6D71DBA122}"/>
+                <a16:creationId xmlns:a16="http://schemas.microsoft.com/office/drawing/2014/main" id="{7A2D7F8D-6938-489F-BB8A-CEE6EEC24A88}"/>
               </a:ext>
             </a:extLst>
           </p:cNvPr>
@@ -3998,7 +3998,7 @@
           <p:cNvPr id="6" name="welcome-p-5">
             <a:extLst xmlns:a="http://schemas.openxmlformats.org/drawingml/2006/main">
               <a:ext uri="{FF2B5EF4-FFF2-40B4-BE49-F238E27FC236}">
-                <a16:creationId xmlns:a16="http://schemas.microsoft.com/office/drawing/2014/main" id="{8F66741A-56EF-4EDC-BC73-316FD9A95902}"/>
+                <a16:creationId xmlns:a16="http://schemas.microsoft.com/office/drawing/2014/main" id="{5DC36686-2048-46C7-AF2C-9FF3270708BC}"/>
               </a:ext>
             </a:extLst>
           </p:cNvPr>
@@ -4066,7 +4066,7 @@
           <p:cNvPr id="7" name="welcome-p-6">
             <a:extLst xmlns:a="http://schemas.openxmlformats.org/drawingml/2006/main">
               <a:ext uri="{FF2B5EF4-FFF2-40B4-BE49-F238E27FC236}">
-                <a16:creationId xmlns:a16="http://schemas.microsoft.com/office/drawing/2014/main" id="{B48BE267-7DCA-487D-8F6C-8649CDDA755A}"/>
+                <a16:creationId xmlns:a16="http://schemas.microsoft.com/office/drawing/2014/main" id="{FC996B36-E9FC-4067-8F5E-FB357A22F4DD}"/>
               </a:ext>
             </a:extLst>
           </p:cNvPr>
@@ -4134,7 +4134,7 @@
           <p:cNvPr id="8" name="welcome-span-7">
             <a:extLst xmlns:a="http://schemas.openxmlformats.org/drawingml/2006/main">
               <a:ext uri="{FF2B5EF4-FFF2-40B4-BE49-F238E27FC236}">
-                <a16:creationId xmlns:a16="http://schemas.microsoft.com/office/drawing/2014/main" id="{D8F99385-32A5-4AD6-9104-404727C87273}"/>
+                <a16:creationId xmlns:a16="http://schemas.microsoft.com/office/drawing/2014/main" id="{CE53062E-4B15-457D-8F39-CB019851548C}"/>
               </a:ext>
             </a:extLst>
           </p:cNvPr>
@@ -4202,7 +4202,7 @@
           <p:cNvPr id="9" name="welcome-span-8">
             <a:extLst xmlns:a="http://schemas.openxmlformats.org/drawingml/2006/main">
               <a:ext uri="{FF2B5EF4-FFF2-40B4-BE49-F238E27FC236}">
-                <a16:creationId xmlns:a16="http://schemas.microsoft.com/office/drawing/2014/main" id="{62C9A668-2731-4AB2-BB21-16C524116F9B}"/>
+                <a16:creationId xmlns:a16="http://schemas.microsoft.com/office/drawing/2014/main" id="{84B9A7EA-363C-4115-AFAC-508ED4956786}"/>
               </a:ext>
             </a:extLst>
           </p:cNvPr>
@@ -4268,7 +4268,7 @@
     </p:spTree>
     <p:extLst>
       <p:ext uri="{BB962C8B-B14F-4D97-AF65-F5344CB8AC3E}">
-        <p14:creationId xmlns:p14="http://schemas.microsoft.com/office/powerpoint/2010/main" val="616074209"/>
+        <p14:creationId xmlns:p14="http://schemas.microsoft.com/office/powerpoint/2010/main" val="1384911744"/>
       </p:ext>
     </p:extLst>
   </p:cSld>
@@ -4299,7 +4299,7 @@
           <p:cNvPr id="18" name="">
             <a:extLst xmlns:a="http://schemas.openxmlformats.org/drawingml/2006/main">
               <a:ext uri="{FF2B5EF4-FFF2-40B4-BE49-F238E27FC236}">
-                <a16:creationId xmlns:a16="http://schemas.microsoft.com/office/drawing/2014/main" id="{24E1E480-21E7-4543-9324-3FB3B181373B}"/>
+                <a16:creationId xmlns:a16="http://schemas.microsoft.com/office/drawing/2014/main" id="{112D986C-3669-453A-87EA-0A9352B8B612}"/>
               </a:ext>
             </a:extLst>
           </p:cNvPr>
@@ -4309,7 +4309,7 @@
           <p:nvPr/>
         </p:nvPicPr>
         <p:blipFill>
-          <a:blip xmlns:r="http://schemas.openxmlformats.org/officeDocument/2006/relationships" xmlns:a="http://schemas.openxmlformats.org/drawingml/2006/main" r:embed="R22a95336b43f4ba8"/>
+          <a:blip xmlns:r="http://schemas.openxmlformats.org/officeDocument/2006/relationships" xmlns:a="http://schemas.openxmlformats.org/drawingml/2006/main" r:embed="Rdcb2d91f61154b21"/>
           <a:stretch xmlns:a="http://schemas.openxmlformats.org/drawingml/2006/main"/>
         </p:blipFill>
         <p:spPr>
@@ -4327,7 +4327,7 @@
           <p:cNvPr id="2" name="">
             <a:extLst xmlns:a="http://schemas.openxmlformats.org/drawingml/2006/main">
               <a:ext uri="{FF2B5EF4-FFF2-40B4-BE49-F238E27FC236}">
-                <a16:creationId xmlns:a16="http://schemas.microsoft.com/office/drawing/2014/main" id="{B3F2A8E3-1A57-410C-A862-77FEBF456AB6}"/>
+                <a16:creationId xmlns:a16="http://schemas.microsoft.com/office/drawing/2014/main" id="{B6DFB3BA-7BEF-490A-BC0E-2116BAC773D9}"/>
               </a:ext>
             </a:extLst>
           </p:cNvPr>
@@ -4337,7 +4337,7 @@
           <p:nvPr/>
         </p:nvPicPr>
         <p:blipFill>
-          <a:blip xmlns:r="http://schemas.openxmlformats.org/officeDocument/2006/relationships" xmlns:a="http://schemas.openxmlformats.org/drawingml/2006/main" r:embed="Rac3fca87d02e4c8b"/>
+          <a:blip xmlns:r="http://schemas.openxmlformats.org/officeDocument/2006/relationships" xmlns:a="http://schemas.openxmlformats.org/drawingml/2006/main" r:embed="Rc508757cf50b4d5b"/>
           <a:stretch xmlns:a="http://schemas.openxmlformats.org/drawingml/2006/main"/>
         </p:blipFill>
         <p:spPr>
@@ -4355,7 +4355,7 @@
           <p:cNvPr id="3" name="">
             <a:extLst xmlns:a="http://schemas.openxmlformats.org/drawingml/2006/main">
               <a:ext uri="{FF2B5EF4-FFF2-40B4-BE49-F238E27FC236}">
-                <a16:creationId xmlns:a16="http://schemas.microsoft.com/office/drawing/2014/main" id="{4284C1A1-25B9-4781-95FE-6FD6535A3C0E}"/>
+                <a16:creationId xmlns:a16="http://schemas.microsoft.com/office/drawing/2014/main" id="{F4F8DE9C-F580-45E5-B1A8-47CDF1BD50B6}"/>
               </a:ext>
             </a:extLst>
           </p:cNvPr>
@@ -4365,7 +4365,7 @@
           <p:nvPr/>
         </p:nvPicPr>
         <p:blipFill>
-          <a:blip xmlns:r="http://schemas.openxmlformats.org/officeDocument/2006/relationships" xmlns:a="http://schemas.openxmlformats.org/drawingml/2006/main" r:embed="R1eba9593c2fa4a51"/>
+          <a:blip xmlns:r="http://schemas.openxmlformats.org/officeDocument/2006/relationships" xmlns:a="http://schemas.openxmlformats.org/drawingml/2006/main" r:embed="Re1c16c3390ac42f9"/>
           <a:stretch xmlns:a="http://schemas.openxmlformats.org/drawingml/2006/main"/>
         </p:blipFill>
         <p:spPr>
@@ -4383,7 +4383,7 @@
           <p:cNvPr id="4" name="">
             <a:extLst xmlns:a="http://schemas.openxmlformats.org/drawingml/2006/main">
               <a:ext uri="{FF2B5EF4-FFF2-40B4-BE49-F238E27FC236}">
-                <a16:creationId xmlns:a16="http://schemas.microsoft.com/office/drawing/2014/main" id="{5DE51316-3E73-4EAD-BADB-20AA4B35C27E}"/>
+                <a16:creationId xmlns:a16="http://schemas.microsoft.com/office/drawing/2014/main" id="{A4DB4F64-DA85-452E-8315-D3212080E127}"/>
               </a:ext>
             </a:extLst>
           </p:cNvPr>
@@ -4393,7 +4393,7 @@
           <p:nvPr/>
         </p:nvPicPr>
         <p:blipFill>
-          <a:blip xmlns:r="http://schemas.openxmlformats.org/officeDocument/2006/relationships" xmlns:a="http://schemas.openxmlformats.org/drawingml/2006/main" r:embed="Rc4459fceffe04608"/>
+          <a:blip xmlns:r="http://schemas.openxmlformats.org/officeDocument/2006/relationships" xmlns:a="http://schemas.openxmlformats.org/drawingml/2006/main" r:embed="R91bcd7eb9d134709"/>
           <a:stretch xmlns:a="http://schemas.openxmlformats.org/drawingml/2006/main"/>
         </p:blipFill>
         <p:spPr>
@@ -4411,7 +4411,7 @@
           <p:cNvPr id="5" name="">
             <a:extLst xmlns:a="http://schemas.openxmlformats.org/drawingml/2006/main">
               <a:ext uri="{FF2B5EF4-FFF2-40B4-BE49-F238E27FC236}">
-                <a16:creationId xmlns:a16="http://schemas.microsoft.com/office/drawing/2014/main" id="{56C2949A-ACD5-4BB9-84DE-117B1225C987}"/>
+                <a16:creationId xmlns:a16="http://schemas.microsoft.com/office/drawing/2014/main" id="{2B594D93-61B7-4C8F-A968-056DDED13FE6}"/>
               </a:ext>
             </a:extLst>
           </p:cNvPr>
@@ -4421,7 +4421,7 @@
           <p:nvPr/>
         </p:nvPicPr>
         <p:blipFill>
-          <a:blip xmlns:r="http://schemas.openxmlformats.org/officeDocument/2006/relationships" xmlns:a="http://schemas.openxmlformats.org/drawingml/2006/main" r:embed="R7cb787120987428c"/>
+          <a:blip xmlns:r="http://schemas.openxmlformats.org/officeDocument/2006/relationships" xmlns:a="http://schemas.openxmlformats.org/drawingml/2006/main" r:embed="R659a950576144a12"/>
           <a:stretch xmlns:a="http://schemas.openxmlformats.org/drawingml/2006/main"/>
         </p:blipFill>
         <p:spPr>
@@ -4439,7 +4439,7 @@
           <p:cNvPr id="6" name="">
             <a:extLst xmlns:a="http://schemas.openxmlformats.org/drawingml/2006/main">
               <a:ext uri="{FF2B5EF4-FFF2-40B4-BE49-F238E27FC236}">
-                <a16:creationId xmlns:a16="http://schemas.microsoft.com/office/drawing/2014/main" id="{4E88C2E7-B6F3-4929-A0B0-6BF3C8F24E28}"/>
+                <a16:creationId xmlns:a16="http://schemas.microsoft.com/office/drawing/2014/main" id="{9142EDD8-A895-43BE-93BA-523BA0B1F0FC}"/>
               </a:ext>
             </a:extLst>
           </p:cNvPr>
@@ -4449,7 +4449,7 @@
           <p:nvPr/>
         </p:nvPicPr>
         <p:blipFill>
-          <a:blip xmlns:r="http://schemas.openxmlformats.org/officeDocument/2006/relationships" xmlns:a="http://schemas.openxmlformats.org/drawingml/2006/main" r:embed="Reb963811301d4822"/>
+          <a:blip xmlns:r="http://schemas.openxmlformats.org/officeDocument/2006/relationships" xmlns:a="http://schemas.openxmlformats.org/drawingml/2006/main" r:embed="R73d5d6b8f2324438"/>
           <a:stretch xmlns:a="http://schemas.openxmlformats.org/drawingml/2006/main"/>
         </p:blipFill>
         <p:spPr>
@@ -4467,7 +4467,7 @@
           <p:cNvPr id="7" name="">
             <a:extLst xmlns:a="http://schemas.openxmlformats.org/drawingml/2006/main">
               <a:ext uri="{FF2B5EF4-FFF2-40B4-BE49-F238E27FC236}">
-                <a16:creationId xmlns:a16="http://schemas.microsoft.com/office/drawing/2014/main" id="{36784B88-7E51-47CF-8392-258D34C4493B}"/>
+                <a16:creationId xmlns:a16="http://schemas.microsoft.com/office/drawing/2014/main" id="{D5045E70-F48A-4850-A306-0B2C200CCB0D}"/>
               </a:ext>
             </a:extLst>
           </p:cNvPr>
@@ -4477,13 +4477,13 @@
           <p:nvPr/>
         </p:nvPicPr>
         <p:blipFill>
-          <a:blip xmlns:r="http://schemas.openxmlformats.org/officeDocument/2006/relationships" xmlns:a="http://schemas.openxmlformats.org/drawingml/2006/main" r:embed="Rce036e9074dd406c"/>
+          <a:blip xmlns:r="http://schemas.openxmlformats.org/officeDocument/2006/relationships" xmlns:a="http://schemas.openxmlformats.org/drawingml/2006/main" r:embed="R37a6495d7be74c0d"/>
           <a:stretch xmlns:a="http://schemas.openxmlformats.org/drawingml/2006/main"/>
         </p:blipFill>
         <p:spPr>
           <a:xfrm xmlns:a="http://schemas.openxmlformats.org/drawingml/2006/main">
-            <a:off x="1049111" y="7178576"/>
-            <a:ext cx="3375230" cy="682526"/>
+            <a:off x="932468" y="7078712"/>
+            <a:ext cx="1445002" cy="466130"/>
           </a:xfrm>
           <a:prstGeom xmlns:a="http://schemas.openxmlformats.org/drawingml/2006/main" prst="rect">
             <a:avLst/>
@@ -4495,7 +4495,7 @@
           <p:cNvPr id="8" name="">
             <a:extLst xmlns:a="http://schemas.openxmlformats.org/drawingml/2006/main">
               <a:ext uri="{FF2B5EF4-FFF2-40B4-BE49-F238E27FC236}">
-                <a16:creationId xmlns:a16="http://schemas.microsoft.com/office/drawing/2014/main" id="{3DECEDA6-A5F4-4CD9-9C75-0DF4B1BE4409}"/>
+                <a16:creationId xmlns:a16="http://schemas.microsoft.com/office/drawing/2014/main" id="{BDEE4D85-3C73-44BF-8DB3-008BA06A45BB}"/>
               </a:ext>
             </a:extLst>
           </p:cNvPr>
@@ -4505,7 +4505,7 @@
           <p:nvPr/>
         </p:nvPicPr>
         <p:blipFill>
-          <a:blip xmlns:r="http://schemas.openxmlformats.org/officeDocument/2006/relationships" xmlns:a="http://schemas.openxmlformats.org/drawingml/2006/main" r:embed="R5957ce34b055416f"/>
+          <a:blip xmlns:r="http://schemas.openxmlformats.org/officeDocument/2006/relationships" xmlns:a="http://schemas.openxmlformats.org/drawingml/2006/main" r:embed="R89be8c03d2f2409b"/>
           <a:stretch xmlns:a="http://schemas.openxmlformats.org/drawingml/2006/main"/>
         </p:blipFill>
         <p:spPr>
@@ -4523,7 +4523,7 @@
           <p:cNvPr id="9" name="sponsors-span-1">
             <a:extLst xmlns:a="http://schemas.openxmlformats.org/drawingml/2006/main">
               <a:ext uri="{FF2B5EF4-FFF2-40B4-BE49-F238E27FC236}">
-                <a16:creationId xmlns:a16="http://schemas.microsoft.com/office/drawing/2014/main" id="{5779705D-D03E-4BE8-93A5-22ADF8809AF9}"/>
+                <a16:creationId xmlns:a16="http://schemas.microsoft.com/office/drawing/2014/main" id="{6BE773B7-0679-4A8F-AE91-0D166C920987}"/>
               </a:ext>
             </a:extLst>
           </p:cNvPr>
@@ -4591,7 +4591,7 @@
           <p:cNvPr id="10" name="sponsors-span-2">
             <a:extLst xmlns:a="http://schemas.openxmlformats.org/drawingml/2006/main">
               <a:ext uri="{FF2B5EF4-FFF2-40B4-BE49-F238E27FC236}">
-                <a16:creationId xmlns:a16="http://schemas.microsoft.com/office/drawing/2014/main" id="{C3373BD2-7C65-4BD9-BCD6-D18F4DD053F9}"/>
+                <a16:creationId xmlns:a16="http://schemas.microsoft.com/office/drawing/2014/main" id="{C1B3E54F-A0A4-467D-8065-31E0BD8D4879}"/>
               </a:ext>
             </a:extLst>
           </p:cNvPr>
@@ -4659,7 +4659,7 @@
           <p:cNvPr id="11" name="sponsors-h1-3">
             <a:extLst xmlns:a="http://schemas.openxmlformats.org/drawingml/2006/main">
               <a:ext uri="{FF2B5EF4-FFF2-40B4-BE49-F238E27FC236}">
-                <a16:creationId xmlns:a16="http://schemas.microsoft.com/office/drawing/2014/main" id="{A6CDA669-6DEE-4DFA-903A-74E82505D2F0}"/>
+                <a16:creationId xmlns:a16="http://schemas.microsoft.com/office/drawing/2014/main" id="{2D35298C-6E37-4215-80D6-F0EDDA9E40E3}"/>
               </a:ext>
             </a:extLst>
           </p:cNvPr>
@@ -4727,7 +4727,7 @@
           <p:cNvPr id="12" name="sponsors-h2-4">
             <a:extLst xmlns:a="http://schemas.openxmlformats.org/drawingml/2006/main">
               <a:ext uri="{FF2B5EF4-FFF2-40B4-BE49-F238E27FC236}">
-                <a16:creationId xmlns:a16="http://schemas.microsoft.com/office/drawing/2014/main" id="{2EE1D4EB-5971-4B7E-B199-3C12D36163A3}"/>
+                <a16:creationId xmlns:a16="http://schemas.microsoft.com/office/drawing/2014/main" id="{DB28AF3B-8C19-4906-9F31-B373D1796FD6}"/>
               </a:ext>
             </a:extLst>
           </p:cNvPr>
@@ -4795,7 +4795,7 @@
           <p:cNvPr id="13" name="sponsors-h2-5">
             <a:extLst xmlns:a="http://schemas.openxmlformats.org/drawingml/2006/main">
               <a:ext uri="{FF2B5EF4-FFF2-40B4-BE49-F238E27FC236}">
-                <a16:creationId xmlns:a16="http://schemas.microsoft.com/office/drawing/2014/main" id="{F710A71E-B505-4376-A16D-573369334EA0}"/>
+                <a16:creationId xmlns:a16="http://schemas.microsoft.com/office/drawing/2014/main" id="{589BBB5C-69A6-4ECB-99AB-3ECA80C4AEF1}"/>
               </a:ext>
             </a:extLst>
           </p:cNvPr>
@@ -4863,7 +4863,7 @@
           <p:cNvPr id="14" name="sponsors-h2-6">
             <a:extLst xmlns:a="http://schemas.openxmlformats.org/drawingml/2006/main">
               <a:ext uri="{FF2B5EF4-FFF2-40B4-BE49-F238E27FC236}">
-                <a16:creationId xmlns:a16="http://schemas.microsoft.com/office/drawing/2014/main" id="{39BA92D8-FC00-4D94-8941-791B03170B7A}"/>
+                <a16:creationId xmlns:a16="http://schemas.microsoft.com/office/drawing/2014/main" id="{E1F01D95-3825-4246-9D31-93886E7DDE71}"/>
               </a:ext>
             </a:extLst>
           </p:cNvPr>
@@ -4931,7 +4931,7 @@
           <p:cNvPr id="15" name="sponsors-h2-7">
             <a:extLst xmlns:a="http://schemas.openxmlformats.org/drawingml/2006/main">
               <a:ext uri="{FF2B5EF4-FFF2-40B4-BE49-F238E27FC236}">
-                <a16:creationId xmlns:a16="http://schemas.microsoft.com/office/drawing/2014/main" id="{7FBC673C-3BCE-46D6-B6A3-A6A4E8ADA380}"/>
+                <a16:creationId xmlns:a16="http://schemas.microsoft.com/office/drawing/2014/main" id="{FF358152-7D73-472F-82FC-803583DFB2CA}"/>
               </a:ext>
             </a:extLst>
           </p:cNvPr>
@@ -4999,7 +4999,7 @@
           <p:cNvPr id="16" name="sponsors-span-8">
             <a:extLst xmlns:a="http://schemas.openxmlformats.org/drawingml/2006/main">
               <a:ext uri="{FF2B5EF4-FFF2-40B4-BE49-F238E27FC236}">
-                <a16:creationId xmlns:a16="http://schemas.microsoft.com/office/drawing/2014/main" id="{A831C00B-A5E7-40F0-82DE-9A9F0C384A98}"/>
+                <a16:creationId xmlns:a16="http://schemas.microsoft.com/office/drawing/2014/main" id="{6905A6F2-4D81-44B0-8B03-DF71C79D4908}"/>
               </a:ext>
             </a:extLst>
           </p:cNvPr>
@@ -5067,7 +5067,7 @@
           <p:cNvPr id="17" name="sponsors-span-9">
             <a:extLst xmlns:a="http://schemas.openxmlformats.org/drawingml/2006/main">
               <a:ext uri="{FF2B5EF4-FFF2-40B4-BE49-F238E27FC236}">
-                <a16:creationId xmlns:a16="http://schemas.microsoft.com/office/drawing/2014/main" id="{D0AA7FD3-7643-4599-96AC-DB32313156B3}"/>
+                <a16:creationId xmlns:a16="http://schemas.microsoft.com/office/drawing/2014/main" id="{BF3502D4-35C7-4249-BB3C-473E19F9CE73}"/>
               </a:ext>
             </a:extLst>
           </p:cNvPr>
@@ -5133,7 +5133,7 @@
     </p:spTree>
     <p:extLst>
       <p:ext uri="{BB962C8B-B14F-4D97-AF65-F5344CB8AC3E}">
-        <p14:creationId xmlns:p14="http://schemas.microsoft.com/office/powerpoint/2010/main" val="1069065335"/>
+        <p14:creationId xmlns:p14="http://schemas.microsoft.com/office/powerpoint/2010/main" val="1472744014"/>
       </p:ext>
     </p:extLst>
   </p:cSld>
@@ -5164,7 +5164,7 @@
           <p:cNvPr id="12" name="">
             <a:extLst xmlns:a="http://schemas.openxmlformats.org/drawingml/2006/main">
               <a:ext uri="{FF2B5EF4-FFF2-40B4-BE49-F238E27FC236}">
-                <a16:creationId xmlns:a16="http://schemas.microsoft.com/office/drawing/2014/main" id="{C0E7047B-575D-4246-897C-479090DEA60E}"/>
+                <a16:creationId xmlns:a16="http://schemas.microsoft.com/office/drawing/2014/main" id="{37D324F7-97A8-461E-9EE3-F95D2E74BDD7}"/>
               </a:ext>
             </a:extLst>
           </p:cNvPr>
@@ -5174,7 +5174,7 @@
           <p:nvPr/>
         </p:nvPicPr>
         <p:blipFill>
-          <a:blip xmlns:r="http://schemas.openxmlformats.org/officeDocument/2006/relationships" xmlns:a="http://schemas.openxmlformats.org/drawingml/2006/main" r:embed="Rfb3f998882a441d1"/>
+          <a:blip xmlns:r="http://schemas.openxmlformats.org/officeDocument/2006/relationships" xmlns:a="http://schemas.openxmlformats.org/drawingml/2006/main" r:embed="Rc831f6fc9b5c4293"/>
           <a:stretch xmlns:a="http://schemas.openxmlformats.org/drawingml/2006/main"/>
         </p:blipFill>
         <p:spPr>
@@ -5192,7 +5192,7 @@
           <p:cNvPr id="2" name="code-of-conduct-span-1">
             <a:extLst xmlns:a="http://schemas.openxmlformats.org/drawingml/2006/main">
               <a:ext uri="{FF2B5EF4-FFF2-40B4-BE49-F238E27FC236}">
-                <a16:creationId xmlns:a16="http://schemas.microsoft.com/office/drawing/2014/main" id="{58B4B905-5B1B-4398-A6DB-2D87B6C381B8}"/>
+                <a16:creationId xmlns:a16="http://schemas.microsoft.com/office/drawing/2014/main" id="{247B05B1-7DDF-4717-9C6A-15AB8E720D0C}"/>
               </a:ext>
             </a:extLst>
           </p:cNvPr>
@@ -5260,7 +5260,7 @@
           <p:cNvPr id="3" name="code-of-conduct-span-2">
             <a:extLst xmlns:a="http://schemas.openxmlformats.org/drawingml/2006/main">
               <a:ext uri="{FF2B5EF4-FFF2-40B4-BE49-F238E27FC236}">
-                <a16:creationId xmlns:a16="http://schemas.microsoft.com/office/drawing/2014/main" id="{43948FDF-D831-4BD4-8E63-C4B4E0FAB642}"/>
+                <a16:creationId xmlns:a16="http://schemas.microsoft.com/office/drawing/2014/main" id="{08539EB1-7643-40CB-805D-BE23BC3D37E7}"/>
               </a:ext>
             </a:extLst>
           </p:cNvPr>
@@ -5328,7 +5328,7 @@
           <p:cNvPr id="4" name="code-of-conduct-h1-3">
             <a:extLst xmlns:a="http://schemas.openxmlformats.org/drawingml/2006/main">
               <a:ext uri="{FF2B5EF4-FFF2-40B4-BE49-F238E27FC236}">
-                <a16:creationId xmlns:a16="http://schemas.microsoft.com/office/drawing/2014/main" id="{7298817B-B7C6-4625-A1D0-97245A799183}"/>
+                <a16:creationId xmlns:a16="http://schemas.microsoft.com/office/drawing/2014/main" id="{134FC5BC-DAED-4B90-9126-4CB546EDF068}"/>
               </a:ext>
             </a:extLst>
           </p:cNvPr>
@@ -5396,7 +5396,7 @@
           <p:cNvPr id="5" name="code-of-conduct-h1-4">
             <a:extLst xmlns:a="http://schemas.openxmlformats.org/drawingml/2006/main">
               <a:ext uri="{FF2B5EF4-FFF2-40B4-BE49-F238E27FC236}">
-                <a16:creationId xmlns:a16="http://schemas.microsoft.com/office/drawing/2014/main" id="{498545D3-5483-4B75-BF76-C1FEFDC32709}"/>
+                <a16:creationId xmlns:a16="http://schemas.microsoft.com/office/drawing/2014/main" id="{82FB8202-5309-4AEE-89F6-9760B60A9A62}"/>
               </a:ext>
             </a:extLst>
           </p:cNvPr>
@@ -5464,7 +5464,7 @@
           <p:cNvPr id="6" name="code-of-conduct-p-5">
             <a:extLst xmlns:a="http://schemas.openxmlformats.org/drawingml/2006/main">
               <a:ext uri="{FF2B5EF4-FFF2-40B4-BE49-F238E27FC236}">
-                <a16:creationId xmlns:a16="http://schemas.microsoft.com/office/drawing/2014/main" id="{F9AE6EAC-0BBD-47B3-BCD6-B1339BCD2BD7}"/>
+                <a16:creationId xmlns:a16="http://schemas.microsoft.com/office/drawing/2014/main" id="{ED359679-1223-4B3D-A29E-0AD4BEBD9641}"/>
               </a:ext>
             </a:extLst>
           </p:cNvPr>
@@ -5532,7 +5532,7 @@
           <p:cNvPr id="7" name="code-of-conduct-p-6">
             <a:extLst xmlns:a="http://schemas.openxmlformats.org/drawingml/2006/main">
               <a:ext uri="{FF2B5EF4-FFF2-40B4-BE49-F238E27FC236}">
-                <a16:creationId xmlns:a16="http://schemas.microsoft.com/office/drawing/2014/main" id="{E7DCCFFE-B048-4640-8CE8-EE704BE298E7}"/>
+                <a16:creationId xmlns:a16="http://schemas.microsoft.com/office/drawing/2014/main" id="{90B88AF8-0A09-4697-918E-972960424914}"/>
               </a:ext>
             </a:extLst>
           </p:cNvPr>
@@ -5600,7 +5600,7 @@
           <p:cNvPr id="8" name="code-of-conduct-p-7">
             <a:extLst xmlns:a="http://schemas.openxmlformats.org/drawingml/2006/main">
               <a:ext uri="{FF2B5EF4-FFF2-40B4-BE49-F238E27FC236}">
-                <a16:creationId xmlns:a16="http://schemas.microsoft.com/office/drawing/2014/main" id="{D0A66E75-A8BD-41BC-8C79-7C242B38AFDC}"/>
+                <a16:creationId xmlns:a16="http://schemas.microsoft.com/office/drawing/2014/main" id="{0E147700-0639-48E5-94A3-8BE98FFB1232}"/>
               </a:ext>
             </a:extLst>
           </p:cNvPr>
@@ -5668,7 +5668,7 @@
           <p:cNvPr id="9" name="code-of-conduct-a-8">
             <a:extLst xmlns:a="http://schemas.openxmlformats.org/drawingml/2006/main">
               <a:ext uri="{FF2B5EF4-FFF2-40B4-BE49-F238E27FC236}">
-                <a16:creationId xmlns:a16="http://schemas.microsoft.com/office/drawing/2014/main" id="{81F672CD-A13C-4544-AF9F-273A6B3C3067}"/>
+                <a16:creationId xmlns:a16="http://schemas.microsoft.com/office/drawing/2014/main" id="{7F94C4CD-3D09-4D65-8023-6EB2C506B7EB}"/>
               </a:ext>
             </a:extLst>
           </p:cNvPr>
@@ -5725,7 +5725,7 @@
                 <a:latin typeface="Finlandica Text"/>
                 <a:ea typeface="Finlandica Text"/>
                 <a:cs typeface="Finlandica Text"/>
-                <a:hlinkClick xmlns:r="http://schemas.openxmlformats.org/officeDocument/2006/relationships" r:id="R02d7ec7ae689462b"/>
+                <a:hlinkClick xmlns:r="http://schemas.openxmlformats.org/officeDocument/2006/relationships" r:id="R8bfda9b6c11e4787"/>
               </a:rPr>
               <a:t>berlincodeofconduct.org/en</a:t>
             </a:r>
@@ -5737,7 +5737,7 @@
           <p:cNvPr id="10" name="code-of-conduct-span-9">
             <a:extLst xmlns:a="http://schemas.openxmlformats.org/drawingml/2006/main">
               <a:ext uri="{FF2B5EF4-FFF2-40B4-BE49-F238E27FC236}">
-                <a16:creationId xmlns:a16="http://schemas.microsoft.com/office/drawing/2014/main" id="{78F51DEE-5A31-477A-B9BF-BAB39C8CE37B}"/>
+                <a16:creationId xmlns:a16="http://schemas.microsoft.com/office/drawing/2014/main" id="{379BF700-16C7-4403-A942-EADE7E8810DB}"/>
               </a:ext>
             </a:extLst>
           </p:cNvPr>
@@ -5805,7 +5805,7 @@
           <p:cNvPr id="11" name="code-of-conduct-span-10">
             <a:extLst xmlns:a="http://schemas.openxmlformats.org/drawingml/2006/main">
               <a:ext uri="{FF2B5EF4-FFF2-40B4-BE49-F238E27FC236}">
-                <a16:creationId xmlns:a16="http://schemas.microsoft.com/office/drawing/2014/main" id="{218ACAF1-94D2-4B58-ACA1-FBA8FFCB5D80}"/>
+                <a16:creationId xmlns:a16="http://schemas.microsoft.com/office/drawing/2014/main" id="{873D9764-3532-4BA1-9D5E-E2528D6EE715}"/>
               </a:ext>
             </a:extLst>
           </p:cNvPr>
@@ -5871,7 +5871,7 @@
     </p:spTree>
     <p:extLst>
       <p:ext uri="{BB962C8B-B14F-4D97-AF65-F5344CB8AC3E}">
-        <p14:creationId xmlns:p14="http://schemas.microsoft.com/office/powerpoint/2010/main" val="1905444878"/>
+        <p14:creationId xmlns:p14="http://schemas.microsoft.com/office/powerpoint/2010/main" val="2110726617"/>
       </p:ext>
     </p:extLst>
   </p:cSld>
@@ -5902,7 +5902,7 @@
           <p:cNvPr id="9" name="">
             <a:extLst xmlns:a="http://schemas.openxmlformats.org/drawingml/2006/main">
               <a:ext uri="{FF2B5EF4-FFF2-40B4-BE49-F238E27FC236}">
-                <a16:creationId xmlns:a16="http://schemas.microsoft.com/office/drawing/2014/main" id="{237A01EF-562F-4713-829C-22ACE3793F59}"/>
+                <a16:creationId xmlns:a16="http://schemas.microsoft.com/office/drawing/2014/main" id="{700D99B5-0398-4DBB-B606-A83D226DD3F6}"/>
               </a:ext>
             </a:extLst>
           </p:cNvPr>
@@ -5912,7 +5912,7 @@
           <p:nvPr/>
         </p:nvPicPr>
         <p:blipFill>
-          <a:blip xmlns:r="http://schemas.openxmlformats.org/officeDocument/2006/relationships" xmlns:a="http://schemas.openxmlformats.org/drawingml/2006/main" r:embed="R48a49714873d49e5"/>
+          <a:blip xmlns:r="http://schemas.openxmlformats.org/officeDocument/2006/relationships" xmlns:a="http://schemas.openxmlformats.org/drawingml/2006/main" r:embed="Rc9e57f40992840f1"/>
           <a:stretch xmlns:a="http://schemas.openxmlformats.org/drawingml/2006/main"/>
         </p:blipFill>
         <p:spPr>
@@ -5930,7 +5930,7 @@
           <p:cNvPr id="2" name="sdlcai-span-1">
             <a:extLst xmlns:a="http://schemas.openxmlformats.org/drawingml/2006/main">
               <a:ext uri="{FF2B5EF4-FFF2-40B4-BE49-F238E27FC236}">
-                <a16:creationId xmlns:a16="http://schemas.microsoft.com/office/drawing/2014/main" id="{4744C814-CAFD-4AAE-B0FE-96642B297B3B}"/>
+                <a16:creationId xmlns:a16="http://schemas.microsoft.com/office/drawing/2014/main" id="{FBB200E8-2A07-418C-B15D-E18FDA88A7F6}"/>
               </a:ext>
             </a:extLst>
           </p:cNvPr>
@@ -5998,7 +5998,7 @@
           <p:cNvPr id="3" name="sdlcai-span-2">
             <a:extLst xmlns:a="http://schemas.openxmlformats.org/drawingml/2006/main">
               <a:ext uri="{FF2B5EF4-FFF2-40B4-BE49-F238E27FC236}">
-                <a16:creationId xmlns:a16="http://schemas.microsoft.com/office/drawing/2014/main" id="{A794A980-3023-45C1-8B03-F1E7BA1FD4F5}"/>
+                <a16:creationId xmlns:a16="http://schemas.microsoft.com/office/drawing/2014/main" id="{4A4ACD8A-F730-4E7B-A029-7589B949D6C7}"/>
               </a:ext>
             </a:extLst>
           </p:cNvPr>
@@ -6066,7 +6066,7 @@
           <p:cNvPr id="4" name="sdlcai-p-3">
             <a:extLst xmlns:a="http://schemas.openxmlformats.org/drawingml/2006/main">
               <a:ext uri="{FF2B5EF4-FFF2-40B4-BE49-F238E27FC236}">
-                <a16:creationId xmlns:a16="http://schemas.microsoft.com/office/drawing/2014/main" id="{A39E9871-29A9-4C40-BC3E-8619FE52ECE5}"/>
+                <a16:creationId xmlns:a16="http://schemas.microsoft.com/office/drawing/2014/main" id="{65BC2CA0-D60C-40D6-80C3-33EDD7C06B50}"/>
               </a:ext>
             </a:extLst>
           </p:cNvPr>
@@ -6134,7 +6134,7 @@
           <p:cNvPr id="5" name="sdlcai-h1-4">
             <a:extLst xmlns:a="http://schemas.openxmlformats.org/drawingml/2006/main">
               <a:ext uri="{FF2B5EF4-FFF2-40B4-BE49-F238E27FC236}">
-                <a16:creationId xmlns:a16="http://schemas.microsoft.com/office/drawing/2014/main" id="{037EA43C-9C4C-402C-BB17-499FE08CFB1D}"/>
+                <a16:creationId xmlns:a16="http://schemas.microsoft.com/office/drawing/2014/main" id="{623B2BE4-2F94-41BE-BDE0-D981D2401962}"/>
               </a:ext>
             </a:extLst>
           </p:cNvPr>
@@ -6202,7 +6202,7 @@
           <p:cNvPr id="6" name="sdlcai-p-5">
             <a:extLst xmlns:a="http://schemas.openxmlformats.org/drawingml/2006/main">
               <a:ext uri="{FF2B5EF4-FFF2-40B4-BE49-F238E27FC236}">
-                <a16:creationId xmlns:a16="http://schemas.microsoft.com/office/drawing/2014/main" id="{604451C7-FC35-4FCF-A17B-EB16A750D4C7}"/>
+                <a16:creationId xmlns:a16="http://schemas.microsoft.com/office/drawing/2014/main" id="{A0C8F253-139A-4F64-9DA3-7771F9ECF20A}"/>
               </a:ext>
             </a:extLst>
           </p:cNvPr>
@@ -6270,7 +6270,7 @@
           <p:cNvPr id="7" name="sdlcai-span-6">
             <a:extLst xmlns:a="http://schemas.openxmlformats.org/drawingml/2006/main">
               <a:ext uri="{FF2B5EF4-FFF2-40B4-BE49-F238E27FC236}">
-                <a16:creationId xmlns:a16="http://schemas.microsoft.com/office/drawing/2014/main" id="{CE5CDE90-D879-4976-9A4B-41A0542A64A8}"/>
+                <a16:creationId xmlns:a16="http://schemas.microsoft.com/office/drawing/2014/main" id="{A34B37E8-10D8-408F-92A3-AD9D208AD9A1}"/>
               </a:ext>
             </a:extLst>
           </p:cNvPr>
@@ -6338,7 +6338,7 @@
           <p:cNvPr id="8" name="sdlcai-span-7">
             <a:extLst xmlns:a="http://schemas.openxmlformats.org/drawingml/2006/main">
               <a:ext uri="{FF2B5EF4-FFF2-40B4-BE49-F238E27FC236}">
-                <a16:creationId xmlns:a16="http://schemas.microsoft.com/office/drawing/2014/main" id="{05FA8EEA-9C8F-443B-8F29-4CE5F798FC24}"/>
+                <a16:creationId xmlns:a16="http://schemas.microsoft.com/office/drawing/2014/main" id="{C10FEC9D-79DA-4487-8142-D44A170BD001}"/>
               </a:ext>
             </a:extLst>
           </p:cNvPr>
@@ -6404,7 +6404,7 @@
     </p:spTree>
     <p:extLst>
       <p:ext uri="{BB962C8B-B14F-4D97-AF65-F5344CB8AC3E}">
-        <p14:creationId xmlns:p14="http://schemas.microsoft.com/office/powerpoint/2010/main" val="495709863"/>
+        <p14:creationId xmlns:p14="http://schemas.microsoft.com/office/powerpoint/2010/main" val="971415335"/>
       </p:ext>
     </p:extLst>
   </p:cSld>
@@ -6435,7 +6435,7 @@
           <p:cNvPr id="11" name="">
             <a:extLst xmlns:a="http://schemas.openxmlformats.org/drawingml/2006/main">
               <a:ext uri="{FF2B5EF4-FFF2-40B4-BE49-F238E27FC236}">
-                <a16:creationId xmlns:a16="http://schemas.microsoft.com/office/drawing/2014/main" id="{F1823B9D-07EA-434E-906A-F759FFE694D1}"/>
+                <a16:creationId xmlns:a16="http://schemas.microsoft.com/office/drawing/2014/main" id="{7D93D2CF-0CF1-4DC0-864D-77EDE5E8A345}"/>
               </a:ext>
             </a:extLst>
           </p:cNvPr>
@@ -6445,7 +6445,7 @@
           <p:nvPr/>
         </p:nvPicPr>
         <p:blipFill>
-          <a:blip xmlns:r="http://schemas.openxmlformats.org/officeDocument/2006/relationships" xmlns:a="http://schemas.openxmlformats.org/drawingml/2006/main" r:embed="Rb75ae369f8d348c8"/>
+          <a:blip xmlns:r="http://schemas.openxmlformats.org/officeDocument/2006/relationships" xmlns:a="http://schemas.openxmlformats.org/drawingml/2006/main" r:embed="R2accf6ca1a1141c9"/>
           <a:stretch xmlns:a="http://schemas.openxmlformats.org/drawingml/2006/main"/>
         </p:blipFill>
         <p:spPr>
@@ -6463,7 +6463,7 @@
           <p:cNvPr id="2" name="sold-out-span-1">
             <a:extLst xmlns:a="http://schemas.openxmlformats.org/drawingml/2006/main">
               <a:ext uri="{FF2B5EF4-FFF2-40B4-BE49-F238E27FC236}">
-                <a16:creationId xmlns:a16="http://schemas.microsoft.com/office/drawing/2014/main" id="{BB9BB46A-186A-4B65-BE6B-51D2143F0FA9}"/>
+                <a16:creationId xmlns:a16="http://schemas.microsoft.com/office/drawing/2014/main" id="{CDC49B35-1A0C-4B8E-8AC1-7361AC66C2D6}"/>
               </a:ext>
             </a:extLst>
           </p:cNvPr>
@@ -6531,7 +6531,7 @@
           <p:cNvPr id="3" name="sold-out-span-2">
             <a:extLst xmlns:a="http://schemas.openxmlformats.org/drawingml/2006/main">
               <a:ext uri="{FF2B5EF4-FFF2-40B4-BE49-F238E27FC236}">
-                <a16:creationId xmlns:a16="http://schemas.microsoft.com/office/drawing/2014/main" id="{0B0E5E98-F5D3-4605-8A9F-D23DF92AAB56}"/>
+                <a16:creationId xmlns:a16="http://schemas.microsoft.com/office/drawing/2014/main" id="{EDD958CE-1060-4522-B664-81B2D3DB0F87}"/>
               </a:ext>
             </a:extLst>
           </p:cNvPr>
@@ -6599,7 +6599,7 @@
           <p:cNvPr id="4" name="sold-out-p-3">
             <a:extLst xmlns:a="http://schemas.openxmlformats.org/drawingml/2006/main">
               <a:ext uri="{FF2B5EF4-FFF2-40B4-BE49-F238E27FC236}">
-                <a16:creationId xmlns:a16="http://schemas.microsoft.com/office/drawing/2014/main" id="{68CAFB72-DB66-4F06-9733-CF3D56F2DE02}"/>
+                <a16:creationId xmlns:a16="http://schemas.microsoft.com/office/drawing/2014/main" id="{C0988E91-6478-40A5-97DE-612C87911EC5}"/>
               </a:ext>
             </a:extLst>
           </p:cNvPr>
@@ -6667,7 +6667,7 @@
           <p:cNvPr id="5" name="sold-out-h1-4">
             <a:extLst xmlns:a="http://schemas.openxmlformats.org/drawingml/2006/main">
               <a:ext uri="{FF2B5EF4-FFF2-40B4-BE49-F238E27FC236}">
-                <a16:creationId xmlns:a16="http://schemas.microsoft.com/office/drawing/2014/main" id="{41E60265-E393-4D07-A200-5B3D87D6C7FE}"/>
+                <a16:creationId xmlns:a16="http://schemas.microsoft.com/office/drawing/2014/main" id="{21EDA012-B1EA-4494-9095-1CC46E64217E}"/>
               </a:ext>
             </a:extLst>
           </p:cNvPr>
@@ -6735,7 +6735,7 @@
           <p:cNvPr id="6" name="sold-out-p-5">
             <a:extLst xmlns:a="http://schemas.openxmlformats.org/drawingml/2006/main">
               <a:ext uri="{FF2B5EF4-FFF2-40B4-BE49-F238E27FC236}">
-                <a16:creationId xmlns:a16="http://schemas.microsoft.com/office/drawing/2014/main" id="{79D39F3D-33BC-4AE0-A568-835DDA54F2F5}"/>
+                <a16:creationId xmlns:a16="http://schemas.microsoft.com/office/drawing/2014/main" id="{AD57E419-9958-48B3-B810-A3517FA73D9C}"/>
               </a:ext>
             </a:extLst>
           </p:cNvPr>
@@ -6803,7 +6803,7 @@
           <p:cNvPr id="7" name="sold-out-p-6">
             <a:extLst xmlns:a="http://schemas.openxmlformats.org/drawingml/2006/main">
               <a:ext uri="{FF2B5EF4-FFF2-40B4-BE49-F238E27FC236}">
-                <a16:creationId xmlns:a16="http://schemas.microsoft.com/office/drawing/2014/main" id="{92B2D1F4-9B5F-4A96-A393-C2560D8F23A4}"/>
+                <a16:creationId xmlns:a16="http://schemas.microsoft.com/office/drawing/2014/main" id="{E4B30108-0EBD-499B-9EB4-523445FFB757}"/>
               </a:ext>
             </a:extLst>
           </p:cNvPr>
@@ -6871,7 +6871,7 @@
           <p:cNvPr id="8" name="sold-out-p-7">
             <a:extLst xmlns:a="http://schemas.openxmlformats.org/drawingml/2006/main">
               <a:ext uri="{FF2B5EF4-FFF2-40B4-BE49-F238E27FC236}">
-                <a16:creationId xmlns:a16="http://schemas.microsoft.com/office/drawing/2014/main" id="{64EB5DD9-3579-4292-8345-A92B14D7D053}"/>
+                <a16:creationId xmlns:a16="http://schemas.microsoft.com/office/drawing/2014/main" id="{CDFFBE45-14EF-4871-96D8-CE3611270EAB}"/>
               </a:ext>
             </a:extLst>
           </p:cNvPr>
@@ -6939,7 +6939,7 @@
           <p:cNvPr id="9" name="sold-out-span-8">
             <a:extLst xmlns:a="http://schemas.openxmlformats.org/drawingml/2006/main">
               <a:ext uri="{FF2B5EF4-FFF2-40B4-BE49-F238E27FC236}">
-                <a16:creationId xmlns:a16="http://schemas.microsoft.com/office/drawing/2014/main" id="{E97793E9-D37A-47A8-9557-8B6BC41C6477}"/>
+                <a16:creationId xmlns:a16="http://schemas.microsoft.com/office/drawing/2014/main" id="{BD94A5F4-B023-48C8-9968-A2A145C156CA}"/>
               </a:ext>
             </a:extLst>
           </p:cNvPr>
@@ -7007,7 +7007,7 @@
           <p:cNvPr id="10" name="sold-out-span-9">
             <a:extLst xmlns:a="http://schemas.openxmlformats.org/drawingml/2006/main">
               <a:ext uri="{FF2B5EF4-FFF2-40B4-BE49-F238E27FC236}">
-                <a16:creationId xmlns:a16="http://schemas.microsoft.com/office/drawing/2014/main" id="{89E4F4F2-9DC1-4AAF-95F3-9B1E5FC4062F}"/>
+                <a16:creationId xmlns:a16="http://schemas.microsoft.com/office/drawing/2014/main" id="{60AC1AA3-41A5-4C00-B050-F789DC962127}"/>
               </a:ext>
             </a:extLst>
           </p:cNvPr>
@@ -7073,7 +7073,7 @@
     </p:spTree>
     <p:extLst>
       <p:ext uri="{BB962C8B-B14F-4D97-AF65-F5344CB8AC3E}">
-        <p14:creationId xmlns:p14="http://schemas.microsoft.com/office/powerpoint/2010/main" val="34899400"/>
+        <p14:creationId xmlns:p14="http://schemas.microsoft.com/office/powerpoint/2010/main" val="1378131814"/>
       </p:ext>
     </p:extLst>
   </p:cSld>
@@ -7104,7 +7104,7 @@
           <p:cNvPr id="15" name="">
             <a:extLst xmlns:a="http://schemas.openxmlformats.org/drawingml/2006/main">
               <a:ext uri="{FF2B5EF4-FFF2-40B4-BE49-F238E27FC236}">
-                <a16:creationId xmlns:a16="http://schemas.microsoft.com/office/drawing/2014/main" id="{67FA305F-5A3D-4AF7-A4BE-350B644E1DFB}"/>
+                <a16:creationId xmlns:a16="http://schemas.microsoft.com/office/drawing/2014/main" id="{24893824-10D8-4B4D-9BE0-608EBC3A4129}"/>
               </a:ext>
             </a:extLst>
           </p:cNvPr>
@@ -7114,7 +7114,7 @@
           <p:nvPr/>
         </p:nvPicPr>
         <p:blipFill>
-          <a:blip xmlns:r="http://schemas.openxmlformats.org/officeDocument/2006/relationships" xmlns:a="http://schemas.openxmlformats.org/drawingml/2006/main" r:embed="R641ae01cbd9c4cd2"/>
+          <a:blip xmlns:r="http://schemas.openxmlformats.org/officeDocument/2006/relationships" xmlns:a="http://schemas.openxmlformats.org/drawingml/2006/main" r:embed="R09eef2c7960243a9"/>
           <a:stretch xmlns:a="http://schemas.openxmlformats.org/drawingml/2006/main"/>
         </p:blipFill>
         <p:spPr>
@@ -7132,7 +7132,7 @@
           <p:cNvPr id="2" name="themes-span-1">
             <a:extLst xmlns:a="http://schemas.openxmlformats.org/drawingml/2006/main">
               <a:ext uri="{FF2B5EF4-FFF2-40B4-BE49-F238E27FC236}">
-                <a16:creationId xmlns:a16="http://schemas.microsoft.com/office/drawing/2014/main" id="{FB1ABCCB-5DC0-49F4-82A0-BB691ED51359}"/>
+                <a16:creationId xmlns:a16="http://schemas.microsoft.com/office/drawing/2014/main" id="{E7164C2E-1457-4F8D-B99F-607018D08550}"/>
               </a:ext>
             </a:extLst>
           </p:cNvPr>
@@ -7200,7 +7200,7 @@
           <p:cNvPr id="3" name="themes-span-2">
             <a:extLst xmlns:a="http://schemas.openxmlformats.org/drawingml/2006/main">
               <a:ext uri="{FF2B5EF4-FFF2-40B4-BE49-F238E27FC236}">
-                <a16:creationId xmlns:a16="http://schemas.microsoft.com/office/drawing/2014/main" id="{2E355EA3-5DEE-4C5D-884B-0977929DE30A}"/>
+                <a16:creationId xmlns:a16="http://schemas.microsoft.com/office/drawing/2014/main" id="{FA7A10E6-148F-44CB-BB74-72DCF9F80BAC}"/>
               </a:ext>
             </a:extLst>
           </p:cNvPr>
@@ -7268,7 +7268,7 @@
           <p:cNvPr id="4" name="themes-h1-3">
             <a:extLst xmlns:a="http://schemas.openxmlformats.org/drawingml/2006/main">
               <a:ext uri="{FF2B5EF4-FFF2-40B4-BE49-F238E27FC236}">
-                <a16:creationId xmlns:a16="http://schemas.microsoft.com/office/drawing/2014/main" id="{AD33ACE4-73BE-4920-AD56-FEF5324EE084}"/>
+                <a16:creationId xmlns:a16="http://schemas.microsoft.com/office/drawing/2014/main" id="{AD6216EB-5456-4D0E-A1BB-D831D7453F88}"/>
               </a:ext>
             </a:extLst>
           </p:cNvPr>
@@ -7336,7 +7336,7 @@
           <p:cNvPr id="5" name="themes-span-4">
             <a:extLst xmlns:a="http://schemas.openxmlformats.org/drawingml/2006/main">
               <a:ext uri="{FF2B5EF4-FFF2-40B4-BE49-F238E27FC236}">
-                <a16:creationId xmlns:a16="http://schemas.microsoft.com/office/drawing/2014/main" id="{129986C1-8A1D-437F-98B5-9AA089E2A064}"/>
+                <a16:creationId xmlns:a16="http://schemas.microsoft.com/office/drawing/2014/main" id="{F21D98CE-9603-4DD0-8A53-1340EB775089}"/>
               </a:ext>
             </a:extLst>
           </p:cNvPr>
@@ -7404,7 +7404,7 @@
           <p:cNvPr id="6" name="themes-strong-5">
             <a:extLst xmlns:a="http://schemas.openxmlformats.org/drawingml/2006/main">
               <a:ext uri="{FF2B5EF4-FFF2-40B4-BE49-F238E27FC236}">
-                <a16:creationId xmlns:a16="http://schemas.microsoft.com/office/drawing/2014/main" id="{E1816949-49C1-49AA-A29F-6134582E41E7}"/>
+                <a16:creationId xmlns:a16="http://schemas.microsoft.com/office/drawing/2014/main" id="{1FC15BB6-BACC-42A1-98B9-9E08AD6D3682}"/>
               </a:ext>
             </a:extLst>
           </p:cNvPr>
@@ -7472,7 +7472,7 @@
           <p:cNvPr id="7" name="themes-span-6">
             <a:extLst xmlns:a="http://schemas.openxmlformats.org/drawingml/2006/main">
               <a:ext uri="{FF2B5EF4-FFF2-40B4-BE49-F238E27FC236}">
-                <a16:creationId xmlns:a16="http://schemas.microsoft.com/office/drawing/2014/main" id="{2C75D84C-D227-4072-9D0B-89FFDC4C1A12}"/>
+                <a16:creationId xmlns:a16="http://schemas.microsoft.com/office/drawing/2014/main" id="{BC97BC76-1BAB-4B52-B5AF-76D925B2169D}"/>
               </a:ext>
             </a:extLst>
           </p:cNvPr>
@@ -7540,7 +7540,7 @@
           <p:cNvPr id="8" name="themes-strong-7">
             <a:extLst xmlns:a="http://schemas.openxmlformats.org/drawingml/2006/main">
               <a:ext uri="{FF2B5EF4-FFF2-40B4-BE49-F238E27FC236}">
-                <a16:creationId xmlns:a16="http://schemas.microsoft.com/office/drawing/2014/main" id="{73992861-2CD4-4364-9F9C-DA855695BA37}"/>
+                <a16:creationId xmlns:a16="http://schemas.microsoft.com/office/drawing/2014/main" id="{0DA1B8CF-E97E-45AD-93A3-C41DA84BA978}"/>
               </a:ext>
             </a:extLst>
           </p:cNvPr>
@@ -7608,7 +7608,7 @@
           <p:cNvPr id="9" name="themes-strong-8">
             <a:extLst xmlns:a="http://schemas.openxmlformats.org/drawingml/2006/main">
               <a:ext uri="{FF2B5EF4-FFF2-40B4-BE49-F238E27FC236}">
-                <a16:creationId xmlns:a16="http://schemas.microsoft.com/office/drawing/2014/main" id="{5C0B40BD-CAAE-4724-894F-1460F1864E43}"/>
+                <a16:creationId xmlns:a16="http://schemas.microsoft.com/office/drawing/2014/main" id="{B2A25397-14F6-4CF2-B05E-2676526305DC}"/>
               </a:ext>
             </a:extLst>
           </p:cNvPr>
@@ -7676,7 +7676,7 @@
           <p:cNvPr id="10" name="themes-span-9">
             <a:extLst xmlns:a="http://schemas.openxmlformats.org/drawingml/2006/main">
               <a:ext uri="{FF2B5EF4-FFF2-40B4-BE49-F238E27FC236}">
-                <a16:creationId xmlns:a16="http://schemas.microsoft.com/office/drawing/2014/main" id="{C38D7151-2834-4C08-9C03-C6589F9A1D91}"/>
+                <a16:creationId xmlns:a16="http://schemas.microsoft.com/office/drawing/2014/main" id="{F34C234D-C813-4CCE-8148-157B64000417}"/>
               </a:ext>
             </a:extLst>
           </p:cNvPr>
@@ -7744,7 +7744,7 @@
           <p:cNvPr id="11" name="themes-strong-10">
             <a:extLst xmlns:a="http://schemas.openxmlformats.org/drawingml/2006/main">
               <a:ext uri="{FF2B5EF4-FFF2-40B4-BE49-F238E27FC236}">
-                <a16:creationId xmlns:a16="http://schemas.microsoft.com/office/drawing/2014/main" id="{073D9E8C-EE19-4430-B263-A77E96BCC16C}"/>
+                <a16:creationId xmlns:a16="http://schemas.microsoft.com/office/drawing/2014/main" id="{70E53ED7-7453-4787-A5AF-D3C5F92B2B85}"/>
               </a:ext>
             </a:extLst>
           </p:cNvPr>
@@ -7812,7 +7812,7 @@
           <p:cNvPr id="12" name="themes-strong-11">
             <a:extLst xmlns:a="http://schemas.openxmlformats.org/drawingml/2006/main">
               <a:ext uri="{FF2B5EF4-FFF2-40B4-BE49-F238E27FC236}">
-                <a16:creationId xmlns:a16="http://schemas.microsoft.com/office/drawing/2014/main" id="{59241264-2C32-4D93-81D9-FCE0F36F759E}"/>
+                <a16:creationId xmlns:a16="http://schemas.microsoft.com/office/drawing/2014/main" id="{C0D1B760-690F-4DE1-8F28-4B319EF28743}"/>
               </a:ext>
             </a:extLst>
           </p:cNvPr>
@@ -7880,7 +7880,7 @@
           <p:cNvPr id="13" name="themes-span-12">
             <a:extLst xmlns:a="http://schemas.openxmlformats.org/drawingml/2006/main">
               <a:ext uri="{FF2B5EF4-FFF2-40B4-BE49-F238E27FC236}">
-                <a16:creationId xmlns:a16="http://schemas.microsoft.com/office/drawing/2014/main" id="{3A97FD8C-E33B-484A-AE46-2519F1D9F0DF}"/>
+                <a16:creationId xmlns:a16="http://schemas.microsoft.com/office/drawing/2014/main" id="{795F737D-C90E-406D-A8C2-9AC7E75F4B8E}"/>
               </a:ext>
             </a:extLst>
           </p:cNvPr>
@@ -7948,7 +7948,7 @@
           <p:cNvPr id="14" name="themes-span-13">
             <a:extLst xmlns:a="http://schemas.openxmlformats.org/drawingml/2006/main">
               <a:ext uri="{FF2B5EF4-FFF2-40B4-BE49-F238E27FC236}">
-                <a16:creationId xmlns:a16="http://schemas.microsoft.com/office/drawing/2014/main" id="{A65540EB-4035-4F4E-977C-B1A8ACE31F79}"/>
+                <a16:creationId xmlns:a16="http://schemas.microsoft.com/office/drawing/2014/main" id="{9A2F1C61-ECED-4B4E-8968-E6E647842A63}"/>
               </a:ext>
             </a:extLst>
           </p:cNvPr>
@@ -8014,7 +8014,7 @@
     </p:spTree>
     <p:extLst>
       <p:ext uri="{BB962C8B-B14F-4D97-AF65-F5344CB8AC3E}">
-        <p14:creationId xmlns:p14="http://schemas.microsoft.com/office/powerpoint/2010/main" val="106228289"/>
+        <p14:creationId xmlns:p14="http://schemas.microsoft.com/office/powerpoint/2010/main" val="1982385644"/>
       </p:ext>
     </p:extLst>
   </p:cSld>
@@ -8045,7 +8045,7 @@
           <p:cNvPr id="28" name="">
             <a:extLst xmlns:a="http://schemas.openxmlformats.org/drawingml/2006/main">
               <a:ext uri="{FF2B5EF4-FFF2-40B4-BE49-F238E27FC236}">
-                <a16:creationId xmlns:a16="http://schemas.microsoft.com/office/drawing/2014/main" id="{7BF1A661-5EA7-4E2D-A663-7B6D37581E42}"/>
+                <a16:creationId xmlns:a16="http://schemas.microsoft.com/office/drawing/2014/main" id="{A6472F79-5356-4770-90EE-5C676AC6E85C}"/>
               </a:ext>
             </a:extLst>
           </p:cNvPr>
@@ -8055,7 +8055,7 @@
           <p:nvPr/>
         </p:nvPicPr>
         <p:blipFill>
-          <a:blip xmlns:r="http://schemas.openxmlformats.org/officeDocument/2006/relationships" xmlns:a="http://schemas.openxmlformats.org/drawingml/2006/main" r:embed="Rd7e3f5e5cfff4814"/>
+          <a:blip xmlns:r="http://schemas.openxmlformats.org/officeDocument/2006/relationships" xmlns:a="http://schemas.openxmlformats.org/drawingml/2006/main" r:embed="R253cac3a374c4cea"/>
           <a:stretch xmlns:a="http://schemas.openxmlformats.org/drawingml/2006/main"/>
         </p:blipFill>
         <p:spPr>
@@ -8073,7 +8073,7 @@
           <p:cNvPr id="2" name="">
             <a:extLst xmlns:a="http://schemas.openxmlformats.org/drawingml/2006/main">
               <a:ext uri="{FF2B5EF4-FFF2-40B4-BE49-F238E27FC236}">
-                <a16:creationId xmlns:a16="http://schemas.microsoft.com/office/drawing/2014/main" id="{2EB1413D-BC70-45DA-AF9E-821AC8E8AF02}"/>
+                <a16:creationId xmlns:a16="http://schemas.microsoft.com/office/drawing/2014/main" id="{C984267E-12F3-4CCB-8717-0AEA3BD27B06}"/>
               </a:ext>
             </a:extLst>
           </p:cNvPr>
@@ -8083,7 +8083,7 @@
           <p:nvPr/>
         </p:nvPicPr>
         <p:blipFill>
-          <a:blip xmlns:r="http://schemas.openxmlformats.org/officeDocument/2006/relationships" xmlns:a="http://schemas.openxmlformats.org/drawingml/2006/main" r:embed="Rab9843412f604267"/>
+          <a:blip xmlns:r="http://schemas.openxmlformats.org/officeDocument/2006/relationships" xmlns:a="http://schemas.openxmlformats.org/drawingml/2006/main" r:embed="Re596842a09004d93"/>
           <a:stretch xmlns:a="http://schemas.openxmlformats.org/drawingml/2006/main"/>
         </p:blipFill>
         <p:spPr>
@@ -8101,7 +8101,7 @@
           <p:cNvPr id="3" name="">
             <a:extLst xmlns:a="http://schemas.openxmlformats.org/drawingml/2006/main">
               <a:ext uri="{FF2B5EF4-FFF2-40B4-BE49-F238E27FC236}">
-                <a16:creationId xmlns:a16="http://schemas.microsoft.com/office/drawing/2014/main" id="{F5528EC4-B73C-4E32-B3CB-B5B15C083069}"/>
+                <a16:creationId xmlns:a16="http://schemas.microsoft.com/office/drawing/2014/main" id="{870B6872-40A4-4FAE-A567-345E842C30A6}"/>
               </a:ext>
             </a:extLst>
           </p:cNvPr>
@@ -8111,7 +8111,7 @@
           <p:nvPr/>
         </p:nvPicPr>
         <p:blipFill>
-          <a:blip xmlns:r="http://schemas.openxmlformats.org/officeDocument/2006/relationships" xmlns:a="http://schemas.openxmlformats.org/drawingml/2006/main" r:embed="Rb853c20543e64c84"/>
+          <a:blip xmlns:r="http://schemas.openxmlformats.org/officeDocument/2006/relationships" xmlns:a="http://schemas.openxmlformats.org/drawingml/2006/main" r:embed="Ra823c7a9aa1d4383"/>
           <a:stretch xmlns:a="http://schemas.openxmlformats.org/drawingml/2006/main"/>
         </p:blipFill>
         <p:spPr>
@@ -8129,7 +8129,7 @@
           <p:cNvPr id="4" name="">
             <a:extLst xmlns:a="http://schemas.openxmlformats.org/drawingml/2006/main">
               <a:ext uri="{FF2B5EF4-FFF2-40B4-BE49-F238E27FC236}">
-                <a16:creationId xmlns:a16="http://schemas.microsoft.com/office/drawing/2014/main" id="{E4C9B175-8BB8-4AB2-9C28-0F4F4B061D16}"/>
+                <a16:creationId xmlns:a16="http://schemas.microsoft.com/office/drawing/2014/main" id="{34F919AC-D2E5-435F-8C72-9BA8544E0BBD}"/>
               </a:ext>
             </a:extLst>
           </p:cNvPr>
@@ -8139,7 +8139,7 @@
           <p:nvPr/>
         </p:nvPicPr>
         <p:blipFill>
-          <a:blip xmlns:r="http://schemas.openxmlformats.org/officeDocument/2006/relationships" xmlns:a="http://schemas.openxmlformats.org/drawingml/2006/main" r:embed="R970d992c584f4d03"/>
+          <a:blip xmlns:r="http://schemas.openxmlformats.org/officeDocument/2006/relationships" xmlns:a="http://schemas.openxmlformats.org/drawingml/2006/main" r:embed="R714f3da4ebed4625"/>
           <a:stretch xmlns:a="http://schemas.openxmlformats.org/drawingml/2006/main"/>
         </p:blipFill>
         <p:spPr>
@@ -8157,7 +8157,7 @@
           <p:cNvPr id="5" name="">
             <a:extLst xmlns:a="http://schemas.openxmlformats.org/drawingml/2006/main">
               <a:ext uri="{FF2B5EF4-FFF2-40B4-BE49-F238E27FC236}">
-                <a16:creationId xmlns:a16="http://schemas.microsoft.com/office/drawing/2014/main" id="{2EC6F2A0-F92C-4331-8FD8-D23BD0ECADFC}"/>
+                <a16:creationId xmlns:a16="http://schemas.microsoft.com/office/drawing/2014/main" id="{B8DE5F00-92E1-4BC0-A0C7-93FF3A12A059}"/>
               </a:ext>
             </a:extLst>
           </p:cNvPr>
@@ -8167,7 +8167,7 @@
           <p:nvPr/>
         </p:nvPicPr>
         <p:blipFill>
-          <a:blip xmlns:r="http://schemas.openxmlformats.org/officeDocument/2006/relationships" xmlns:a="http://schemas.openxmlformats.org/drawingml/2006/main" r:embed="R9a90e158fb6d4feb"/>
+          <a:blip xmlns:r="http://schemas.openxmlformats.org/officeDocument/2006/relationships" xmlns:a="http://schemas.openxmlformats.org/drawingml/2006/main" r:embed="R5178712320744753"/>
           <a:stretch xmlns:a="http://schemas.openxmlformats.org/drawingml/2006/main"/>
         </p:blipFill>
         <p:spPr>
@@ -8185,7 +8185,7 @@
           <p:cNvPr id="6" name="">
             <a:extLst xmlns:a="http://schemas.openxmlformats.org/drawingml/2006/main">
               <a:ext uri="{FF2B5EF4-FFF2-40B4-BE49-F238E27FC236}">
-                <a16:creationId xmlns:a16="http://schemas.microsoft.com/office/drawing/2014/main" id="{62765020-8891-4EC0-B779-03B37F440474}"/>
+                <a16:creationId xmlns:a16="http://schemas.microsoft.com/office/drawing/2014/main" id="{45A3E37B-A420-4EE6-BE92-A766D0D2F183}"/>
               </a:ext>
             </a:extLst>
           </p:cNvPr>
@@ -8195,7 +8195,7 @@
           <p:nvPr/>
         </p:nvPicPr>
         <p:blipFill>
-          <a:blip xmlns:r="http://schemas.openxmlformats.org/officeDocument/2006/relationships" xmlns:a="http://schemas.openxmlformats.org/drawingml/2006/main" r:embed="Rdcb361cf17db4937"/>
+          <a:blip xmlns:r="http://schemas.openxmlformats.org/officeDocument/2006/relationships" xmlns:a="http://schemas.openxmlformats.org/drawingml/2006/main" r:embed="R7f294e5d457e4d64"/>
           <a:stretch xmlns:a="http://schemas.openxmlformats.org/drawingml/2006/main"/>
         </p:blipFill>
         <p:spPr>
@@ -8213,7 +8213,7 @@
           <p:cNvPr id="7" name="">
             <a:extLst xmlns:a="http://schemas.openxmlformats.org/drawingml/2006/main">
               <a:ext uri="{FF2B5EF4-FFF2-40B4-BE49-F238E27FC236}">
-                <a16:creationId xmlns:a16="http://schemas.microsoft.com/office/drawing/2014/main" id="{B4489088-67EA-41BD-BFD9-8D753E0276EB}"/>
+                <a16:creationId xmlns:a16="http://schemas.microsoft.com/office/drawing/2014/main" id="{4CB6094C-9F11-4B4A-B970-4FDBF3009028}"/>
               </a:ext>
             </a:extLst>
           </p:cNvPr>
@@ -8223,12 +8223,12 @@
           <p:nvPr/>
         </p:nvPicPr>
         <p:blipFill>
-          <a:blip xmlns:r="http://schemas.openxmlformats.org/officeDocument/2006/relationships" xmlns:a="http://schemas.openxmlformats.org/drawingml/2006/main" r:embed="Ref39c72007c64bce"/>
+          <a:blip xmlns:r="http://schemas.openxmlformats.org/officeDocument/2006/relationships" xmlns:a="http://schemas.openxmlformats.org/drawingml/2006/main" r:embed="R8b2246d22fde494e"/>
           <a:stretch xmlns:a="http://schemas.openxmlformats.org/drawingml/2006/main"/>
         </p:blipFill>
         <p:spPr>
           <a:xfrm xmlns:a="http://schemas.openxmlformats.org/drawingml/2006/main">
-            <a:off x="827720" y="6120408"/>
+            <a:off x="827720" y="5823942"/>
             <a:ext cx="2999308" cy="1863923"/>
           </a:xfrm>
           <a:prstGeom xmlns:a="http://schemas.openxmlformats.org/drawingml/2006/main" prst="rect">
@@ -8241,7 +8241,7 @@
           <p:cNvPr id="8" name="">
             <a:extLst xmlns:a="http://schemas.openxmlformats.org/drawingml/2006/main">
               <a:ext uri="{FF2B5EF4-FFF2-40B4-BE49-F238E27FC236}">
-                <a16:creationId xmlns:a16="http://schemas.microsoft.com/office/drawing/2014/main" id="{5D372D2B-FB76-4C45-B228-896A0F16A600}"/>
+                <a16:creationId xmlns:a16="http://schemas.microsoft.com/office/drawing/2014/main" id="{7EE6D816-CAC3-4FE4-87BE-7185211027F1}"/>
               </a:ext>
             </a:extLst>
           </p:cNvPr>
@@ -8251,12 +8251,12 @@
           <p:nvPr/>
         </p:nvPicPr>
         <p:blipFill>
-          <a:blip xmlns:r="http://schemas.openxmlformats.org/officeDocument/2006/relationships" xmlns:a="http://schemas.openxmlformats.org/drawingml/2006/main" r:embed="Race65e0c95c94353"/>
+          <a:blip xmlns:r="http://schemas.openxmlformats.org/officeDocument/2006/relationships" xmlns:a="http://schemas.openxmlformats.org/drawingml/2006/main" r:embed="R53775e459332482b"/>
           <a:stretch xmlns:a="http://schemas.openxmlformats.org/drawingml/2006/main"/>
         </p:blipFill>
         <p:spPr>
           <a:xfrm xmlns:a="http://schemas.openxmlformats.org/drawingml/2006/main">
-            <a:off x="4236033" y="6120408"/>
+            <a:off x="4236033" y="5823942"/>
             <a:ext cx="2999308" cy="1863923"/>
           </a:xfrm>
           <a:prstGeom xmlns:a="http://schemas.openxmlformats.org/drawingml/2006/main" prst="rect">
@@ -8269,7 +8269,7 @@
           <p:cNvPr id="9" name="">
             <a:extLst xmlns:a="http://schemas.openxmlformats.org/drawingml/2006/main">
               <a:ext uri="{FF2B5EF4-FFF2-40B4-BE49-F238E27FC236}">
-                <a16:creationId xmlns:a16="http://schemas.microsoft.com/office/drawing/2014/main" id="{28C94EFE-F7E8-4FE3-A854-BE711C7D872B}"/>
+                <a16:creationId xmlns:a16="http://schemas.microsoft.com/office/drawing/2014/main" id="{EEF67BA6-5E9C-4193-980D-FB7E7AF6DDCA}"/>
               </a:ext>
             </a:extLst>
           </p:cNvPr>
@@ -8279,12 +8279,12 @@
           <p:nvPr/>
         </p:nvPicPr>
         <p:blipFill>
-          <a:blip xmlns:r="http://schemas.openxmlformats.org/officeDocument/2006/relationships" xmlns:a="http://schemas.openxmlformats.org/drawingml/2006/main" r:embed="R167795090ecb42a6"/>
+          <a:blip xmlns:r="http://schemas.openxmlformats.org/officeDocument/2006/relationships" xmlns:a="http://schemas.openxmlformats.org/drawingml/2006/main" r:embed="Rdf76811db2a54dd5"/>
           <a:stretch xmlns:a="http://schemas.openxmlformats.org/drawingml/2006/main"/>
         </p:blipFill>
         <p:spPr>
           <a:xfrm xmlns:a="http://schemas.openxmlformats.org/drawingml/2006/main">
-            <a:off x="7649077" y="6120408"/>
+            <a:off x="7649077" y="5823942"/>
             <a:ext cx="2989847" cy="1863923"/>
           </a:xfrm>
           <a:prstGeom xmlns:a="http://schemas.openxmlformats.org/drawingml/2006/main" prst="rect">
@@ -8297,7 +8297,7 @@
           <p:cNvPr id="10" name="">
             <a:extLst xmlns:a="http://schemas.openxmlformats.org/drawingml/2006/main">
               <a:ext uri="{FF2B5EF4-FFF2-40B4-BE49-F238E27FC236}">
-                <a16:creationId xmlns:a16="http://schemas.microsoft.com/office/drawing/2014/main" id="{AB50BB9F-438B-4CFE-ABB3-EBB186E61256}"/>
+                <a16:creationId xmlns:a16="http://schemas.microsoft.com/office/drawing/2014/main" id="{28DC6C34-DB6E-4663-A448-48D52621721B}"/>
               </a:ext>
             </a:extLst>
           </p:cNvPr>
@@ -8307,12 +8307,12 @@
           <p:nvPr/>
         </p:nvPicPr>
         <p:blipFill>
-          <a:blip xmlns:r="http://schemas.openxmlformats.org/officeDocument/2006/relationships" xmlns:a="http://schemas.openxmlformats.org/drawingml/2006/main" r:embed="Recee1164cd3c4457"/>
+          <a:blip xmlns:r="http://schemas.openxmlformats.org/officeDocument/2006/relationships" xmlns:a="http://schemas.openxmlformats.org/drawingml/2006/main" r:embed="R68598722ee9a4b8d"/>
           <a:stretch xmlns:a="http://schemas.openxmlformats.org/drawingml/2006/main"/>
         </p:blipFill>
         <p:spPr>
           <a:xfrm xmlns:a="http://schemas.openxmlformats.org/drawingml/2006/main">
-            <a:off x="11052659" y="6120408"/>
+            <a:off x="11052659" y="5823942"/>
             <a:ext cx="2999308" cy="1863923"/>
           </a:xfrm>
           <a:prstGeom xmlns:a="http://schemas.openxmlformats.org/drawingml/2006/main" prst="rect">
@@ -8325,7 +8325,7 @@
           <p:cNvPr id="11" name="">
             <a:extLst xmlns:a="http://schemas.openxmlformats.org/drawingml/2006/main">
               <a:ext uri="{FF2B5EF4-FFF2-40B4-BE49-F238E27FC236}">
-                <a16:creationId xmlns:a16="http://schemas.microsoft.com/office/drawing/2014/main" id="{084776FE-59EF-459A-A33E-D985115CD9BC}"/>
+                <a16:creationId xmlns:a16="http://schemas.microsoft.com/office/drawing/2014/main" id="{25A9FAEA-0BDE-4E91-84A4-FAA327815152}"/>
               </a:ext>
             </a:extLst>
           </p:cNvPr>
@@ -8335,12 +8335,12 @@
           <p:nvPr/>
         </p:nvPicPr>
         <p:blipFill>
-          <a:blip xmlns:r="http://schemas.openxmlformats.org/officeDocument/2006/relationships" xmlns:a="http://schemas.openxmlformats.org/drawingml/2006/main" r:embed="R34d0c143594b483c"/>
+          <a:blip xmlns:r="http://schemas.openxmlformats.org/officeDocument/2006/relationships" xmlns:a="http://schemas.openxmlformats.org/drawingml/2006/main" r:embed="R046f364e48464cf0"/>
           <a:stretch xmlns:a="http://schemas.openxmlformats.org/drawingml/2006/main"/>
         </p:blipFill>
         <p:spPr>
           <a:xfrm xmlns:a="http://schemas.openxmlformats.org/drawingml/2006/main">
-            <a:off x="14460972" y="6120408"/>
+            <a:off x="14460972" y="5823942"/>
             <a:ext cx="2999308" cy="1863923"/>
           </a:xfrm>
           <a:prstGeom xmlns:a="http://schemas.openxmlformats.org/drawingml/2006/main" prst="rect">
@@ -8353,7 +8353,7 @@
           <p:cNvPr id="12" name="speakers-span-1">
             <a:extLst xmlns:a="http://schemas.openxmlformats.org/drawingml/2006/main">
               <a:ext uri="{FF2B5EF4-FFF2-40B4-BE49-F238E27FC236}">
-                <a16:creationId xmlns:a16="http://schemas.microsoft.com/office/drawing/2014/main" id="{FCC201EF-6C82-4BA8-8EF9-F6CB44A28AC7}"/>
+                <a16:creationId xmlns:a16="http://schemas.microsoft.com/office/drawing/2014/main" id="{8E15528E-117C-4AD9-8F5A-7C3AEC43D5E0}"/>
               </a:ext>
             </a:extLst>
           </p:cNvPr>
@@ -8421,7 +8421,7 @@
           <p:cNvPr id="13" name="speakers-span-2">
             <a:extLst xmlns:a="http://schemas.openxmlformats.org/drawingml/2006/main">
               <a:ext uri="{FF2B5EF4-FFF2-40B4-BE49-F238E27FC236}">
-                <a16:creationId xmlns:a16="http://schemas.microsoft.com/office/drawing/2014/main" id="{0C7949C5-B26A-4E89-B323-82965EEFAEBD}"/>
+                <a16:creationId xmlns:a16="http://schemas.microsoft.com/office/drawing/2014/main" id="{99A0F4A0-2A34-47AE-88D6-2638A99BF62C}"/>
               </a:ext>
             </a:extLst>
           </p:cNvPr>
@@ -8489,7 +8489,7 @@
           <p:cNvPr id="14" name="speakers-h1-3">
             <a:extLst xmlns:a="http://schemas.openxmlformats.org/drawingml/2006/main">
               <a:ext uri="{FF2B5EF4-FFF2-40B4-BE49-F238E27FC236}">
-                <a16:creationId xmlns:a16="http://schemas.microsoft.com/office/drawing/2014/main" id="{4BAA30CA-D40D-4137-AEAB-DE26170EB6DA}"/>
+                <a16:creationId xmlns:a16="http://schemas.microsoft.com/office/drawing/2014/main" id="{82175FB0-6564-48A3-80A9-13FAD9B2BC2B}"/>
               </a:ext>
             </a:extLst>
           </p:cNvPr>
@@ -8557,7 +8557,7 @@
           <p:cNvPr id="15" name="speakers-figcaption-4">
             <a:extLst xmlns:a="http://schemas.openxmlformats.org/drawingml/2006/main">
               <a:ext uri="{FF2B5EF4-FFF2-40B4-BE49-F238E27FC236}">
-                <a16:creationId xmlns:a16="http://schemas.microsoft.com/office/drawing/2014/main" id="{66A9581A-1791-40A3-B99D-49CE7B561B2A}"/>
+                <a16:creationId xmlns:a16="http://schemas.microsoft.com/office/drawing/2014/main" id="{7D046D61-8B61-41EE-B65A-39014B0EA8A1}"/>
               </a:ext>
             </a:extLst>
           </p:cNvPr>
@@ -8625,7 +8625,7 @@
           <p:cNvPr id="16" name="speakers-figcaption-5">
             <a:extLst xmlns:a="http://schemas.openxmlformats.org/drawingml/2006/main">
               <a:ext uri="{FF2B5EF4-FFF2-40B4-BE49-F238E27FC236}">
-                <a16:creationId xmlns:a16="http://schemas.microsoft.com/office/drawing/2014/main" id="{6B67F1A9-FC61-45BA-9A40-8399D0178C48}"/>
+                <a16:creationId xmlns:a16="http://schemas.microsoft.com/office/drawing/2014/main" id="{B9DB927A-D71A-4BEA-9EE0-5C5FC2577499}"/>
               </a:ext>
             </a:extLst>
           </p:cNvPr>
@@ -8693,7 +8693,7 @@
           <p:cNvPr id="17" name="speakers-figcaption-6">
             <a:extLst xmlns:a="http://schemas.openxmlformats.org/drawingml/2006/main">
               <a:ext uri="{FF2B5EF4-FFF2-40B4-BE49-F238E27FC236}">
-                <a16:creationId xmlns:a16="http://schemas.microsoft.com/office/drawing/2014/main" id="{2CCF9B30-C310-4774-8CBB-49EABA13FF73}"/>
+                <a16:creationId xmlns:a16="http://schemas.microsoft.com/office/drawing/2014/main" id="{03C91937-7359-4600-B89D-A073EC4DA6AB}"/>
               </a:ext>
             </a:extLst>
           </p:cNvPr>
@@ -8761,7 +8761,7 @@
           <p:cNvPr id="18" name="speakers-figcaption-7">
             <a:extLst xmlns:a="http://schemas.openxmlformats.org/drawingml/2006/main">
               <a:ext uri="{FF2B5EF4-FFF2-40B4-BE49-F238E27FC236}">
-                <a16:creationId xmlns:a16="http://schemas.microsoft.com/office/drawing/2014/main" id="{F595E1E1-C06D-41D5-9791-D32346BDDA98}"/>
+                <a16:creationId xmlns:a16="http://schemas.microsoft.com/office/drawing/2014/main" id="{C164A95E-3C5A-4520-8A81-2BC177732833}"/>
               </a:ext>
             </a:extLst>
           </p:cNvPr>
@@ -8773,7 +8773,7 @@
         <p:spPr>
           <a:xfrm xmlns:a="http://schemas.openxmlformats.org/drawingml/2006/main">
             <a:off x="11047809" y="5191562"/>
-            <a:ext cx="2238077" cy="362468"/>
+            <a:ext cx="2470100" cy="362468"/>
           </a:xfrm>
           <a:prstGeom xmlns:a="http://schemas.openxmlformats.org/drawingml/2006/main" prst="rect">
             <a:avLst/>
@@ -8819,7 +8819,7 @@
                 <a:ea typeface="Finlandica Text"/>
                 <a:cs typeface="Finlandica Text"/>
               </a:rPr>
-              <a:t>Dr Muhammad</a:t>
+              <a:t>Tapio Pitkäranta</a:t>
             </a:r>
           </a:p>
         </p:txBody>
@@ -8829,19 +8829,19 @@
           <p:cNvPr id="19" name="speakers-figcaption-8">
             <a:extLst xmlns:a="http://schemas.openxmlformats.org/drawingml/2006/main">
               <a:ext uri="{FF2B5EF4-FFF2-40B4-BE49-F238E27FC236}">
-                <a16:creationId xmlns:a16="http://schemas.microsoft.com/office/drawing/2014/main" id="{2C5A2AE5-9550-41CE-AF93-5D530F9DF99C}"/>
-              </a:ext>
-            </a:extLst>
-          </p:cNvPr>
-          <p:cNvSpPr>
-            <a:spLocks xmlns:a="http://schemas.openxmlformats.org/drawingml/2006/main" noGrp="1"/>
-          </p:cNvSpPr>
-          <p:nvPr/>
-        </p:nvSpPr>
-        <p:spPr>
-          <a:xfrm xmlns:a="http://schemas.openxmlformats.org/drawingml/2006/main">
-            <a:off x="11047809" y="5488028"/>
-            <a:ext cx="1381571" cy="362468"/>
+                <a16:creationId xmlns:a16="http://schemas.microsoft.com/office/drawing/2014/main" id="{3EFA0C5A-D010-4787-BB49-3F3815F27253}"/>
+              </a:ext>
+            </a:extLst>
+          </p:cNvPr>
+          <p:cNvSpPr>
+            <a:spLocks xmlns:a="http://schemas.openxmlformats.org/drawingml/2006/main" noGrp="1"/>
+          </p:cNvSpPr>
+          <p:nvPr/>
+        </p:nvSpPr>
+        <p:spPr>
+          <a:xfrm xmlns:a="http://schemas.openxmlformats.org/drawingml/2006/main">
+            <a:off x="14456122" y="5191562"/>
+            <a:ext cx="1831032" cy="362468"/>
           </a:xfrm>
           <a:prstGeom xmlns:a="http://schemas.openxmlformats.org/drawingml/2006/main" prst="rect">
             <a:avLst/>
@@ -8887,7 +8887,7 @@
                 <a:ea typeface="Finlandica Text"/>
                 <a:cs typeface="Finlandica Text"/>
               </a:rPr>
-              <a:t>Waseem</a:t>
+              <a:t>Joongi Shin</a:t>
             </a:r>
           </a:p>
         </p:txBody>
@@ -8897,19 +8897,19 @@
           <p:cNvPr id="20" name="speakers-figcaption-9">
             <a:extLst xmlns:a="http://schemas.openxmlformats.org/drawingml/2006/main">
               <a:ext uri="{FF2B5EF4-FFF2-40B4-BE49-F238E27FC236}">
-                <a16:creationId xmlns:a16="http://schemas.microsoft.com/office/drawing/2014/main" id="{28C1811F-9CD2-4157-AB59-964A5A47280F}"/>
-              </a:ext>
-            </a:extLst>
-          </p:cNvPr>
-          <p:cNvSpPr>
-            <a:spLocks xmlns:a="http://schemas.openxmlformats.org/drawingml/2006/main" noGrp="1"/>
-          </p:cNvSpPr>
-          <p:nvPr/>
-        </p:nvSpPr>
-        <p:spPr>
-          <a:xfrm xmlns:a="http://schemas.openxmlformats.org/drawingml/2006/main">
-            <a:off x="14456122" y="5191562"/>
-            <a:ext cx="2470100" cy="362468"/>
+                <a16:creationId xmlns:a16="http://schemas.microsoft.com/office/drawing/2014/main" id="{B438D9E6-F830-45CE-8E99-0FEE27AC19E0}"/>
+              </a:ext>
+            </a:extLst>
+          </p:cNvPr>
+          <p:cNvSpPr>
+            <a:spLocks xmlns:a="http://schemas.openxmlformats.org/drawingml/2006/main" noGrp="1"/>
+          </p:cNvSpPr>
+          <p:nvPr/>
+        </p:nvSpPr>
+        <p:spPr>
+          <a:xfrm xmlns:a="http://schemas.openxmlformats.org/drawingml/2006/main">
+            <a:off x="822871" y="7759443"/>
+            <a:ext cx="1983284" cy="362468"/>
           </a:xfrm>
           <a:prstGeom xmlns:a="http://schemas.openxmlformats.org/drawingml/2006/main" prst="rect">
             <a:avLst/>
@@ -8955,7 +8955,7 @@
                 <a:ea typeface="Finlandica Text"/>
                 <a:cs typeface="Finlandica Text"/>
               </a:rPr>
-              <a:t>Tapio Pitkäranta</a:t>
+              <a:t>Jussi Hacklin</a:t>
             </a:r>
           </a:p>
         </p:txBody>
@@ -8965,19 +8965,19 @@
           <p:cNvPr id="21" name="speakers-figcaption-10">
             <a:extLst xmlns:a="http://schemas.openxmlformats.org/drawingml/2006/main">
               <a:ext uri="{FF2B5EF4-FFF2-40B4-BE49-F238E27FC236}">
-                <a16:creationId xmlns:a16="http://schemas.microsoft.com/office/drawing/2014/main" id="{4860F137-7811-4147-B39C-9218D6BE09B2}"/>
-              </a:ext>
-            </a:extLst>
-          </p:cNvPr>
-          <p:cNvSpPr>
-            <a:spLocks xmlns:a="http://schemas.openxmlformats.org/drawingml/2006/main" noGrp="1"/>
-          </p:cNvSpPr>
-          <p:nvPr/>
-        </p:nvSpPr>
-        <p:spPr>
-          <a:xfrm xmlns:a="http://schemas.openxmlformats.org/drawingml/2006/main">
-            <a:off x="822871" y="8055908"/>
-            <a:ext cx="1831032" cy="362468"/>
+                <a16:creationId xmlns:a16="http://schemas.microsoft.com/office/drawing/2014/main" id="{950E0E55-F608-493B-B0C1-844D23F70DEF}"/>
+              </a:ext>
+            </a:extLst>
+          </p:cNvPr>
+          <p:cNvSpPr>
+            <a:spLocks xmlns:a="http://schemas.openxmlformats.org/drawingml/2006/main" noGrp="1"/>
+          </p:cNvSpPr>
+          <p:nvPr/>
+        </p:nvSpPr>
+        <p:spPr>
+          <a:xfrm xmlns:a="http://schemas.openxmlformats.org/drawingml/2006/main">
+            <a:off x="4231184" y="7759443"/>
+            <a:ext cx="2838748" cy="362468"/>
           </a:xfrm>
           <a:prstGeom xmlns:a="http://schemas.openxmlformats.org/drawingml/2006/main" prst="rect">
             <a:avLst/>
@@ -9023,7 +9023,7 @@
                 <a:ea typeface="Finlandica Text"/>
                 <a:cs typeface="Finlandica Text"/>
               </a:rPr>
-              <a:t>Joongi Shin</a:t>
+              <a:t>Viljami Kuosmanen</a:t>
             </a:r>
           </a:p>
         </p:txBody>
@@ -9033,19 +9033,19 @@
           <p:cNvPr id="22" name="speakers-figcaption-11">
             <a:extLst xmlns:a="http://schemas.openxmlformats.org/drawingml/2006/main">
               <a:ext uri="{FF2B5EF4-FFF2-40B4-BE49-F238E27FC236}">
-                <a16:creationId xmlns:a16="http://schemas.microsoft.com/office/drawing/2014/main" id="{DEFBADE2-ADB2-47BC-9596-077249C236C1}"/>
-              </a:ext>
-            </a:extLst>
-          </p:cNvPr>
-          <p:cNvSpPr>
-            <a:spLocks xmlns:a="http://schemas.openxmlformats.org/drawingml/2006/main" noGrp="1"/>
-          </p:cNvSpPr>
-          <p:nvPr/>
-        </p:nvSpPr>
-        <p:spPr>
-          <a:xfrm xmlns:a="http://schemas.openxmlformats.org/drawingml/2006/main">
-            <a:off x="4231184" y="8055908"/>
-            <a:ext cx="1983284" cy="362468"/>
+                <a16:creationId xmlns:a16="http://schemas.microsoft.com/office/drawing/2014/main" id="{9E655DCC-1161-40D8-88AC-45F4F0390A91}"/>
+              </a:ext>
+            </a:extLst>
+          </p:cNvPr>
+          <p:cNvSpPr>
+            <a:spLocks xmlns:a="http://schemas.openxmlformats.org/drawingml/2006/main" noGrp="1"/>
+          </p:cNvSpPr>
+          <p:nvPr/>
+        </p:nvSpPr>
+        <p:spPr>
+          <a:xfrm xmlns:a="http://schemas.openxmlformats.org/drawingml/2006/main">
+            <a:off x="7639496" y="7759443"/>
+            <a:ext cx="2187625" cy="362468"/>
           </a:xfrm>
           <a:prstGeom xmlns:a="http://schemas.openxmlformats.org/drawingml/2006/main" prst="rect">
             <a:avLst/>
@@ -9091,7 +9091,7 @@
                 <a:ea typeface="Finlandica Text"/>
                 <a:cs typeface="Finlandica Text"/>
               </a:rPr>
-              <a:t>Jussi Hacklin</a:t>
+              <a:t>Sini Tistelgrén</a:t>
             </a:r>
           </a:p>
         </p:txBody>
@@ -9101,19 +9101,19 @@
           <p:cNvPr id="23" name="speakers-figcaption-12">
             <a:extLst xmlns:a="http://schemas.openxmlformats.org/drawingml/2006/main">
               <a:ext uri="{FF2B5EF4-FFF2-40B4-BE49-F238E27FC236}">
-                <a16:creationId xmlns:a16="http://schemas.microsoft.com/office/drawing/2014/main" id="{0FF9ED3D-3975-4CF4-8122-58A3033A263E}"/>
-              </a:ext>
-            </a:extLst>
-          </p:cNvPr>
-          <p:cNvSpPr>
-            <a:spLocks xmlns:a="http://schemas.openxmlformats.org/drawingml/2006/main" noGrp="1"/>
-          </p:cNvSpPr>
-          <p:nvPr/>
-        </p:nvSpPr>
-        <p:spPr>
-          <a:xfrm xmlns:a="http://schemas.openxmlformats.org/drawingml/2006/main">
-            <a:off x="7639496" y="8055908"/>
-            <a:ext cx="2838748" cy="362468"/>
+                <a16:creationId xmlns:a16="http://schemas.microsoft.com/office/drawing/2014/main" id="{8D8DA9B6-21DE-4F3D-B7B1-E398E06CE553}"/>
+              </a:ext>
+            </a:extLst>
+          </p:cNvPr>
+          <p:cNvSpPr>
+            <a:spLocks xmlns:a="http://schemas.openxmlformats.org/drawingml/2006/main" noGrp="1"/>
+          </p:cNvSpPr>
+          <p:nvPr/>
+        </p:nvSpPr>
+        <p:spPr>
+          <a:xfrm xmlns:a="http://schemas.openxmlformats.org/drawingml/2006/main">
+            <a:off x="11047809" y="7759443"/>
+            <a:ext cx="1384697" cy="362468"/>
           </a:xfrm>
           <a:prstGeom xmlns:a="http://schemas.openxmlformats.org/drawingml/2006/main" prst="rect">
             <a:avLst/>
@@ -9159,7 +9159,7 @@
                 <a:ea typeface="Finlandica Text"/>
                 <a:cs typeface="Finlandica Text"/>
               </a:rPr>
-              <a:t>Viljami Kuosmanen</a:t>
+              <a:t>Zak Allal</a:t>
             </a:r>
           </a:p>
         </p:txBody>
@@ -9169,19 +9169,19 @@
           <p:cNvPr id="24" name="speakers-figcaption-13">
             <a:extLst xmlns:a="http://schemas.openxmlformats.org/drawingml/2006/main">
               <a:ext uri="{FF2B5EF4-FFF2-40B4-BE49-F238E27FC236}">
-                <a16:creationId xmlns:a16="http://schemas.microsoft.com/office/drawing/2014/main" id="{863EC00C-BB1E-40F0-B2B2-52E460875277}"/>
-              </a:ext>
-            </a:extLst>
-          </p:cNvPr>
-          <p:cNvSpPr>
-            <a:spLocks xmlns:a="http://schemas.openxmlformats.org/drawingml/2006/main" noGrp="1"/>
-          </p:cNvSpPr>
-          <p:nvPr/>
-        </p:nvSpPr>
-        <p:spPr>
-          <a:xfrm xmlns:a="http://schemas.openxmlformats.org/drawingml/2006/main">
-            <a:off x="11047809" y="8055908"/>
-            <a:ext cx="2187625" cy="362468"/>
+                <a16:creationId xmlns:a16="http://schemas.microsoft.com/office/drawing/2014/main" id="{4B354E3E-24E4-4837-BB7B-B7FEDFD17DF0}"/>
+              </a:ext>
+            </a:extLst>
+          </p:cNvPr>
+          <p:cNvSpPr>
+            <a:spLocks xmlns:a="http://schemas.openxmlformats.org/drawingml/2006/main" noGrp="1"/>
+          </p:cNvSpPr>
+          <p:nvPr/>
+        </p:nvSpPr>
+        <p:spPr>
+          <a:xfrm xmlns:a="http://schemas.openxmlformats.org/drawingml/2006/main">
+            <a:off x="14456122" y="7759443"/>
+            <a:ext cx="2238077" cy="362468"/>
           </a:xfrm>
           <a:prstGeom xmlns:a="http://schemas.openxmlformats.org/drawingml/2006/main" prst="rect">
             <a:avLst/>
@@ -9227,7 +9227,7 @@
                 <a:ea typeface="Finlandica Text"/>
                 <a:cs typeface="Finlandica Text"/>
               </a:rPr>
-              <a:t>Sini Tistelgrén</a:t>
+              <a:t>Dr Muhammad</a:t>
             </a:r>
           </a:p>
         </p:txBody>
@@ -9237,7 +9237,7 @@
           <p:cNvPr id="25" name="speakers-figcaption-14">
             <a:extLst xmlns:a="http://schemas.openxmlformats.org/drawingml/2006/main">
               <a:ext uri="{FF2B5EF4-FFF2-40B4-BE49-F238E27FC236}">
-                <a16:creationId xmlns:a16="http://schemas.microsoft.com/office/drawing/2014/main" id="{D3836F33-6A82-4C6C-8A45-DCB37A94492E}"/>
+                <a16:creationId xmlns:a16="http://schemas.microsoft.com/office/drawing/2014/main" id="{B2AC7604-9D10-444F-9ED6-3A5667D47F2D}"/>
               </a:ext>
             </a:extLst>
           </p:cNvPr>
@@ -9249,7 +9249,7 @@
         <p:spPr>
           <a:xfrm xmlns:a="http://schemas.openxmlformats.org/drawingml/2006/main">
             <a:off x="14456122" y="8055908"/>
-            <a:ext cx="1384697" cy="362468"/>
+            <a:ext cx="1381571" cy="362468"/>
           </a:xfrm>
           <a:prstGeom xmlns:a="http://schemas.openxmlformats.org/drawingml/2006/main" prst="rect">
             <a:avLst/>
@@ -9295,7 +9295,7 @@
                 <a:ea typeface="Finlandica Text"/>
                 <a:cs typeface="Finlandica Text"/>
               </a:rPr>
-              <a:t>Zak Allal</a:t>
+              <a:t>Waseem</a:t>
             </a:r>
           </a:p>
         </p:txBody>
@@ -9305,7 +9305,7 @@
           <p:cNvPr id="26" name="speakers-span-15">
             <a:extLst xmlns:a="http://schemas.openxmlformats.org/drawingml/2006/main">
               <a:ext uri="{FF2B5EF4-FFF2-40B4-BE49-F238E27FC236}">
-                <a16:creationId xmlns:a16="http://schemas.microsoft.com/office/drawing/2014/main" id="{82CE00E2-7518-4C06-97A7-7053EE5511A8}"/>
+                <a16:creationId xmlns:a16="http://schemas.microsoft.com/office/drawing/2014/main" id="{7CF03782-F551-4020-8368-92022B63E325}"/>
               </a:ext>
             </a:extLst>
           </p:cNvPr>
@@ -9373,7 +9373,7 @@
           <p:cNvPr id="27" name="speakers-span-16">
             <a:extLst xmlns:a="http://schemas.openxmlformats.org/drawingml/2006/main">
               <a:ext uri="{FF2B5EF4-FFF2-40B4-BE49-F238E27FC236}">
-                <a16:creationId xmlns:a16="http://schemas.microsoft.com/office/drawing/2014/main" id="{5B75F688-12EF-4832-815E-40BF1D29AAFF}"/>
+                <a16:creationId xmlns:a16="http://schemas.microsoft.com/office/drawing/2014/main" id="{CD10ECA5-A494-4932-8576-E26FC797E8BE}"/>
               </a:ext>
             </a:extLst>
           </p:cNvPr>
@@ -9439,7 +9439,7 @@
     </p:spTree>
     <p:extLst>
       <p:ext uri="{BB962C8B-B14F-4D97-AF65-F5344CB8AC3E}">
-        <p14:creationId xmlns:p14="http://schemas.microsoft.com/office/powerpoint/2010/main" val="2067384573"/>
+        <p14:creationId xmlns:p14="http://schemas.microsoft.com/office/powerpoint/2010/main" val="1647374987"/>
       </p:ext>
     </p:extLst>
   </p:cSld>
@@ -9470,7 +9470,7 @@
           <p:cNvPr id="26" name="">
             <a:extLst xmlns:a="http://schemas.openxmlformats.org/drawingml/2006/main">
               <a:ext uri="{FF2B5EF4-FFF2-40B4-BE49-F238E27FC236}">
-                <a16:creationId xmlns:a16="http://schemas.microsoft.com/office/drawing/2014/main" id="{BAD41164-0E3D-4457-9E8B-2905466CDABC}"/>
+                <a16:creationId xmlns:a16="http://schemas.microsoft.com/office/drawing/2014/main" id="{573AF3AA-EF60-4D20-A288-B623717BCFB3}"/>
               </a:ext>
             </a:extLst>
           </p:cNvPr>
@@ -9480,7 +9480,7 @@
           <p:nvPr/>
         </p:nvPicPr>
         <p:blipFill>
-          <a:blip xmlns:r="http://schemas.openxmlformats.org/officeDocument/2006/relationships" xmlns:a="http://schemas.openxmlformats.org/drawingml/2006/main" r:embed="Rd6761b7cae954e06"/>
+          <a:blip xmlns:r="http://schemas.openxmlformats.org/officeDocument/2006/relationships" xmlns:a="http://schemas.openxmlformats.org/drawingml/2006/main" r:embed="R0d90656ba75746ee"/>
           <a:stretch xmlns:a="http://schemas.openxmlformats.org/drawingml/2006/main"/>
         </p:blipFill>
         <p:spPr>
@@ -9498,7 +9498,7 @@
           <p:cNvPr id="2" name="schedule-span-1">
             <a:extLst xmlns:a="http://schemas.openxmlformats.org/drawingml/2006/main">
               <a:ext uri="{FF2B5EF4-FFF2-40B4-BE49-F238E27FC236}">
-                <a16:creationId xmlns:a16="http://schemas.microsoft.com/office/drawing/2014/main" id="{4872F89E-D562-4830-BF3E-F79ED9F71DAA}"/>
+                <a16:creationId xmlns:a16="http://schemas.microsoft.com/office/drawing/2014/main" id="{EC954234-7ED9-4614-BAE4-40C9FD604C0A}"/>
               </a:ext>
             </a:extLst>
           </p:cNvPr>
@@ -9566,7 +9566,7 @@
           <p:cNvPr id="3" name="schedule-span-2">
             <a:extLst xmlns:a="http://schemas.openxmlformats.org/drawingml/2006/main">
               <a:ext uri="{FF2B5EF4-FFF2-40B4-BE49-F238E27FC236}">
-                <a16:creationId xmlns:a16="http://schemas.microsoft.com/office/drawing/2014/main" id="{D7B54857-51B5-46F1-97EC-C720926B43FE}"/>
+                <a16:creationId xmlns:a16="http://schemas.microsoft.com/office/drawing/2014/main" id="{12AE7DD7-147E-4E28-831E-E18668178911}"/>
               </a:ext>
             </a:extLst>
           </p:cNvPr>
@@ -9634,7 +9634,7 @@
           <p:cNvPr id="4" name="schedule-h1-3">
             <a:extLst xmlns:a="http://schemas.openxmlformats.org/drawingml/2006/main">
               <a:ext uri="{FF2B5EF4-FFF2-40B4-BE49-F238E27FC236}">
-                <a16:creationId xmlns:a16="http://schemas.microsoft.com/office/drawing/2014/main" id="{D90E0C5C-4C74-41FA-8C7F-773CDBFF18E7}"/>
+                <a16:creationId xmlns:a16="http://schemas.microsoft.com/office/drawing/2014/main" id="{7187E930-65AB-49D5-86CD-2EDB1B70BD4D}"/>
               </a:ext>
             </a:extLst>
           </p:cNvPr>
@@ -9702,7 +9702,7 @@
           <p:cNvPr id="5" name="schedule-time-4">
             <a:extLst xmlns:a="http://schemas.openxmlformats.org/drawingml/2006/main">
               <a:ext uri="{FF2B5EF4-FFF2-40B4-BE49-F238E27FC236}">
-                <a16:creationId xmlns:a16="http://schemas.microsoft.com/office/drawing/2014/main" id="{9A9AA682-D08F-416A-AD18-8DFAADCFCAD9}"/>
+                <a16:creationId xmlns:a16="http://schemas.microsoft.com/office/drawing/2014/main" id="{12050CD7-B3A5-4ECF-972E-05B63A615168}"/>
               </a:ext>
             </a:extLst>
           </p:cNvPr>
@@ -9770,7 +9770,7 @@
           <p:cNvPr id="6" name="schedule-span-5">
             <a:extLst xmlns:a="http://schemas.openxmlformats.org/drawingml/2006/main">
               <a:ext uri="{FF2B5EF4-FFF2-40B4-BE49-F238E27FC236}">
-                <a16:creationId xmlns:a16="http://schemas.microsoft.com/office/drawing/2014/main" id="{6AEAAC8D-239B-40A2-8E90-F60DA4AAE1B2}"/>
+                <a16:creationId xmlns:a16="http://schemas.microsoft.com/office/drawing/2014/main" id="{35121C10-9298-49B0-9411-229A2D6228C1}"/>
               </a:ext>
             </a:extLst>
           </p:cNvPr>
@@ -9838,7 +9838,7 @@
           <p:cNvPr id="7" name="schedule-time-6">
             <a:extLst xmlns:a="http://schemas.openxmlformats.org/drawingml/2006/main">
               <a:ext uri="{FF2B5EF4-FFF2-40B4-BE49-F238E27FC236}">
-                <a16:creationId xmlns:a16="http://schemas.microsoft.com/office/drawing/2014/main" id="{DE2A44AD-A947-4F2E-957B-B06919659C6A}"/>
+                <a16:creationId xmlns:a16="http://schemas.microsoft.com/office/drawing/2014/main" id="{97169AFA-EE52-45F6-8483-AF50773CB003}"/>
               </a:ext>
             </a:extLst>
           </p:cNvPr>
@@ -9906,7 +9906,7 @@
           <p:cNvPr id="8" name="schedule-span-7">
             <a:extLst xmlns:a="http://schemas.openxmlformats.org/drawingml/2006/main">
               <a:ext uri="{FF2B5EF4-FFF2-40B4-BE49-F238E27FC236}">
-                <a16:creationId xmlns:a16="http://schemas.microsoft.com/office/drawing/2014/main" id="{C932099B-D12A-46B9-B5E7-E080D88E614A}"/>
+                <a16:creationId xmlns:a16="http://schemas.microsoft.com/office/drawing/2014/main" id="{322791C3-ED22-4C86-98A0-98799E1BCC8D}"/>
               </a:ext>
             </a:extLst>
           </p:cNvPr>
@@ -9974,7 +9974,7 @@
           <p:cNvPr id="9" name="schedule-time-8">
             <a:extLst xmlns:a="http://schemas.openxmlformats.org/drawingml/2006/main">
               <a:ext uri="{FF2B5EF4-FFF2-40B4-BE49-F238E27FC236}">
-                <a16:creationId xmlns:a16="http://schemas.microsoft.com/office/drawing/2014/main" id="{D3CEE613-5B91-4300-AF74-69B4F3503E13}"/>
+                <a16:creationId xmlns:a16="http://schemas.microsoft.com/office/drawing/2014/main" id="{24E9E3DD-7CF2-4142-9FD6-78A2E2B4F764}"/>
               </a:ext>
             </a:extLst>
           </p:cNvPr>
@@ -10042,7 +10042,7 @@
           <p:cNvPr id="10" name="schedule-span-9">
             <a:extLst xmlns:a="http://schemas.openxmlformats.org/drawingml/2006/main">
               <a:ext uri="{FF2B5EF4-FFF2-40B4-BE49-F238E27FC236}">
-                <a16:creationId xmlns:a16="http://schemas.microsoft.com/office/drawing/2014/main" id="{2181BFA7-0009-4763-90A5-BC59F9B5D200}"/>
+                <a16:creationId xmlns:a16="http://schemas.microsoft.com/office/drawing/2014/main" id="{0A4B27B5-1F7B-4B84-9580-F925A45D214D}"/>
               </a:ext>
             </a:extLst>
           </p:cNvPr>
@@ -10110,7 +10110,7 @@
           <p:cNvPr id="11" name="schedule-time-10">
             <a:extLst xmlns:a="http://schemas.openxmlformats.org/drawingml/2006/main">
               <a:ext uri="{FF2B5EF4-FFF2-40B4-BE49-F238E27FC236}">
-                <a16:creationId xmlns:a16="http://schemas.microsoft.com/office/drawing/2014/main" id="{D48417A3-FCA5-4DFF-817B-605CDEC23726}"/>
+                <a16:creationId xmlns:a16="http://schemas.microsoft.com/office/drawing/2014/main" id="{11F3E2E2-76B0-4F9F-84F5-770F529E9C30}"/>
               </a:ext>
             </a:extLst>
           </p:cNvPr>
@@ -10178,7 +10178,7 @@
           <p:cNvPr id="12" name="schedule-span-11">
             <a:extLst xmlns:a="http://schemas.openxmlformats.org/drawingml/2006/main">
               <a:ext uri="{FF2B5EF4-FFF2-40B4-BE49-F238E27FC236}">
-                <a16:creationId xmlns:a16="http://schemas.microsoft.com/office/drawing/2014/main" id="{F1BAA3CA-BA1A-4785-B6BE-21941630A57F}"/>
+                <a16:creationId xmlns:a16="http://schemas.microsoft.com/office/drawing/2014/main" id="{B079B940-5EF7-492A-9D88-34DD6A129591}"/>
               </a:ext>
             </a:extLst>
           </p:cNvPr>
@@ -10246,7 +10246,7 @@
           <p:cNvPr id="13" name="schedule-time-12">
             <a:extLst xmlns:a="http://schemas.openxmlformats.org/drawingml/2006/main">
               <a:ext uri="{FF2B5EF4-FFF2-40B4-BE49-F238E27FC236}">
-                <a16:creationId xmlns:a16="http://schemas.microsoft.com/office/drawing/2014/main" id="{5EA41F6F-7E96-45D3-A7B5-A40B8C6B2C4C}"/>
+                <a16:creationId xmlns:a16="http://schemas.microsoft.com/office/drawing/2014/main" id="{81223C07-CCE1-4E4C-8EC0-3478675ACFFA}"/>
               </a:ext>
             </a:extLst>
           </p:cNvPr>
@@ -10314,7 +10314,7 @@
           <p:cNvPr id="14" name="schedule-span-13">
             <a:extLst xmlns:a="http://schemas.openxmlformats.org/drawingml/2006/main">
               <a:ext uri="{FF2B5EF4-FFF2-40B4-BE49-F238E27FC236}">
-                <a16:creationId xmlns:a16="http://schemas.microsoft.com/office/drawing/2014/main" id="{0B3B4D93-353D-45EA-94A2-6AF79DD37F25}"/>
+                <a16:creationId xmlns:a16="http://schemas.microsoft.com/office/drawing/2014/main" id="{5C5DC3A1-D5B8-42FE-BE14-6419F2D499E4}"/>
               </a:ext>
             </a:extLst>
           </p:cNvPr>
@@ -10382,7 +10382,7 @@
           <p:cNvPr id="15" name="schedule-time-14">
             <a:extLst xmlns:a="http://schemas.openxmlformats.org/drawingml/2006/main">
               <a:ext uri="{FF2B5EF4-FFF2-40B4-BE49-F238E27FC236}">
-                <a16:creationId xmlns:a16="http://schemas.microsoft.com/office/drawing/2014/main" id="{7502ED46-37E0-4344-9A98-D270DA9ADAA1}"/>
+                <a16:creationId xmlns:a16="http://schemas.microsoft.com/office/drawing/2014/main" id="{9EBAD949-AC50-44F8-8476-DB6E4EFC27CC}"/>
               </a:ext>
             </a:extLst>
           </p:cNvPr>
@@ -10450,7 +10450,7 @@
           <p:cNvPr id="16" name="schedule-span-15">
             <a:extLst xmlns:a="http://schemas.openxmlformats.org/drawingml/2006/main">
               <a:ext uri="{FF2B5EF4-FFF2-40B4-BE49-F238E27FC236}">
-                <a16:creationId xmlns:a16="http://schemas.microsoft.com/office/drawing/2014/main" id="{2F02AAE1-DB0B-4387-B86A-2C8E55FABCBE}"/>
+                <a16:creationId xmlns:a16="http://schemas.microsoft.com/office/drawing/2014/main" id="{0759C7F5-03CD-4E2A-B698-43CEBDDE313C}"/>
               </a:ext>
             </a:extLst>
           </p:cNvPr>
@@ -10518,7 +10518,7 @@
           <p:cNvPr id="17" name="schedule-time-16">
             <a:extLst xmlns:a="http://schemas.openxmlformats.org/drawingml/2006/main">
               <a:ext uri="{FF2B5EF4-FFF2-40B4-BE49-F238E27FC236}">
-                <a16:creationId xmlns:a16="http://schemas.microsoft.com/office/drawing/2014/main" id="{D1C6921F-B42B-4CB8-979C-F9022F2520E1}"/>
+                <a16:creationId xmlns:a16="http://schemas.microsoft.com/office/drawing/2014/main" id="{79ED0761-4BC7-4D2B-956A-C03549CF97D8}"/>
               </a:ext>
             </a:extLst>
           </p:cNvPr>
@@ -10586,7 +10586,7 @@
           <p:cNvPr id="18" name="schedule-span-17">
             <a:extLst xmlns:a="http://schemas.openxmlformats.org/drawingml/2006/main">
               <a:ext uri="{FF2B5EF4-FFF2-40B4-BE49-F238E27FC236}">
-                <a16:creationId xmlns:a16="http://schemas.microsoft.com/office/drawing/2014/main" id="{63BCF233-F5C9-4AB4-B3C8-A14FDAAA104A}"/>
+                <a16:creationId xmlns:a16="http://schemas.microsoft.com/office/drawing/2014/main" id="{42A478DA-F56A-414E-8256-FA944C8A0902}"/>
               </a:ext>
             </a:extLst>
           </p:cNvPr>
@@ -10654,7 +10654,7 @@
           <p:cNvPr id="19" name="schedule-time-18">
             <a:extLst xmlns:a="http://schemas.openxmlformats.org/drawingml/2006/main">
               <a:ext uri="{FF2B5EF4-FFF2-40B4-BE49-F238E27FC236}">
-                <a16:creationId xmlns:a16="http://schemas.microsoft.com/office/drawing/2014/main" id="{C1835F11-67ED-4EB9-BF60-8B583DCD7FB2}"/>
+                <a16:creationId xmlns:a16="http://schemas.microsoft.com/office/drawing/2014/main" id="{AFEC3958-8175-4722-A09E-72A078BA202B}"/>
               </a:ext>
             </a:extLst>
           </p:cNvPr>
@@ -10722,7 +10722,7 @@
           <p:cNvPr id="20" name="schedule-span-19">
             <a:extLst xmlns:a="http://schemas.openxmlformats.org/drawingml/2006/main">
               <a:ext uri="{FF2B5EF4-FFF2-40B4-BE49-F238E27FC236}">
-                <a16:creationId xmlns:a16="http://schemas.microsoft.com/office/drawing/2014/main" id="{08DDC359-BF42-4266-B905-B307CE256187}"/>
+                <a16:creationId xmlns:a16="http://schemas.microsoft.com/office/drawing/2014/main" id="{64247DA7-CFAE-43DE-9351-180FA35E0E34}"/>
               </a:ext>
             </a:extLst>
           </p:cNvPr>
@@ -10790,7 +10790,7 @@
           <p:cNvPr id="21" name="schedule-time-20">
             <a:extLst xmlns:a="http://schemas.openxmlformats.org/drawingml/2006/main">
               <a:ext uri="{FF2B5EF4-FFF2-40B4-BE49-F238E27FC236}">
-                <a16:creationId xmlns:a16="http://schemas.microsoft.com/office/drawing/2014/main" id="{634E0FE3-6B72-4F2B-B18B-A82FCFA3D2AB}"/>
+                <a16:creationId xmlns:a16="http://schemas.microsoft.com/office/drawing/2014/main" id="{02518195-3D7C-4CF4-A313-F171D5986AF8}"/>
               </a:ext>
             </a:extLst>
           </p:cNvPr>
@@ -10858,7 +10858,7 @@
           <p:cNvPr id="22" name="schedule-span-21">
             <a:extLst xmlns:a="http://schemas.openxmlformats.org/drawingml/2006/main">
               <a:ext uri="{FF2B5EF4-FFF2-40B4-BE49-F238E27FC236}">
-                <a16:creationId xmlns:a16="http://schemas.microsoft.com/office/drawing/2014/main" id="{B7E4D9D6-7EFA-40B9-9BA3-F37B6B5DEB78}"/>
+                <a16:creationId xmlns:a16="http://schemas.microsoft.com/office/drawing/2014/main" id="{41F7BCCC-0878-4253-93AA-106C9AC4D1BE}"/>
               </a:ext>
             </a:extLst>
           </p:cNvPr>
@@ -10926,7 +10926,7 @@
           <p:cNvPr id="23" name="schedule-a-22">
             <a:extLst xmlns:a="http://schemas.openxmlformats.org/drawingml/2006/main">
               <a:ext uri="{FF2B5EF4-FFF2-40B4-BE49-F238E27FC236}">
-                <a16:creationId xmlns:a16="http://schemas.microsoft.com/office/drawing/2014/main" id="{833C6618-9693-4B4D-AD63-74352D2D3709}"/>
+                <a16:creationId xmlns:a16="http://schemas.microsoft.com/office/drawing/2014/main" id="{5CBCD542-7C65-4A30-BFE7-2D4DCD8D3764}"/>
               </a:ext>
             </a:extLst>
           </p:cNvPr>
@@ -10983,7 +10983,7 @@
                 <a:latin typeface="Finlandica Text"/>
                 <a:ea typeface="Finlandica Text"/>
                 <a:cs typeface="Finlandica Text"/>
-                <a:hlinkClick xmlns:r="http://schemas.openxmlformats.org/officeDocument/2006/relationships" r:id="R364fcb4fdfee4291"/>
+                <a:hlinkClick xmlns:r="http://schemas.openxmlformats.org/officeDocument/2006/relationships" r:id="Rddcbe1dcdc1b442e"/>
               </a:rPr>
               <a:t>Full programme at sdlcai.org/schedule</a:t>
             </a:r>
@@ -10995,7 +10995,7 @@
           <p:cNvPr id="24" name="schedule-span-23">
             <a:extLst xmlns:a="http://schemas.openxmlformats.org/drawingml/2006/main">
               <a:ext uri="{FF2B5EF4-FFF2-40B4-BE49-F238E27FC236}">
-                <a16:creationId xmlns:a16="http://schemas.microsoft.com/office/drawing/2014/main" id="{400952B7-1384-4270-80A8-F6D25E82DB1D}"/>
+                <a16:creationId xmlns:a16="http://schemas.microsoft.com/office/drawing/2014/main" id="{3D0DDCCF-C8BB-4B24-B79E-D2C007076235}"/>
               </a:ext>
             </a:extLst>
           </p:cNvPr>
@@ -11063,7 +11063,7 @@
           <p:cNvPr id="25" name="schedule-span-24">
             <a:extLst xmlns:a="http://schemas.openxmlformats.org/drawingml/2006/main">
               <a:ext uri="{FF2B5EF4-FFF2-40B4-BE49-F238E27FC236}">
-                <a16:creationId xmlns:a16="http://schemas.microsoft.com/office/drawing/2014/main" id="{90F48066-CDB4-4B65-BD8F-ADA92EBA5E7B}"/>
+                <a16:creationId xmlns:a16="http://schemas.microsoft.com/office/drawing/2014/main" id="{C64BFD08-3909-4AEC-84EE-0C3C57405742}"/>
               </a:ext>
             </a:extLst>
           </p:cNvPr>
@@ -11129,7 +11129,7 @@
     </p:spTree>
     <p:extLst>
       <p:ext uri="{BB962C8B-B14F-4D97-AF65-F5344CB8AC3E}">
-        <p14:creationId xmlns:p14="http://schemas.microsoft.com/office/powerpoint/2010/main" val="623227568"/>
+        <p14:creationId xmlns:p14="http://schemas.microsoft.com/office/powerpoint/2010/main" val="277587209"/>
       </p:ext>
     </p:extLst>
   </p:cSld>
@@ -11160,7 +11160,7 @@
           <p:cNvPr id="10" name="">
             <a:extLst xmlns:a="http://schemas.openxmlformats.org/drawingml/2006/main">
               <a:ext uri="{FF2B5EF4-FFF2-40B4-BE49-F238E27FC236}">
-                <a16:creationId xmlns:a16="http://schemas.microsoft.com/office/drawing/2014/main" id="{36DADDEE-E52E-4EB3-9649-58DB2581892D}"/>
+                <a16:creationId xmlns:a16="http://schemas.microsoft.com/office/drawing/2014/main" id="{A660FE2A-602B-4923-8C85-A1E683E699E9}"/>
               </a:ext>
             </a:extLst>
           </p:cNvPr>
@@ -11170,7 +11170,7 @@
           <p:nvPr/>
         </p:nvPicPr>
         <p:blipFill>
-          <a:blip xmlns:r="http://schemas.openxmlformats.org/officeDocument/2006/relationships" xmlns:a="http://schemas.openxmlformats.org/drawingml/2006/main" r:embed="R10516f2dbda046b4"/>
+          <a:blip xmlns:r="http://schemas.openxmlformats.org/officeDocument/2006/relationships" xmlns:a="http://schemas.openxmlformats.org/drawingml/2006/main" r:embed="R88ee644d3e1b48a3"/>
           <a:stretch xmlns:a="http://schemas.openxmlformats.org/drawingml/2006/main"/>
         </p:blipFill>
         <p:spPr>
@@ -11188,7 +11188,7 @@
           <p:cNvPr id="2" name="afterparty-span-1">
             <a:extLst xmlns:a="http://schemas.openxmlformats.org/drawingml/2006/main">
               <a:ext uri="{FF2B5EF4-FFF2-40B4-BE49-F238E27FC236}">
-                <a16:creationId xmlns:a16="http://schemas.microsoft.com/office/drawing/2014/main" id="{4D327A10-6405-4FC5-AD32-47EF53400B68}"/>
+                <a16:creationId xmlns:a16="http://schemas.microsoft.com/office/drawing/2014/main" id="{E5D6A08A-BBB9-42DC-A16E-34CB661CE3D3}"/>
               </a:ext>
             </a:extLst>
           </p:cNvPr>
@@ -11256,7 +11256,7 @@
           <p:cNvPr id="3" name="afterparty-span-2">
             <a:extLst xmlns:a="http://schemas.openxmlformats.org/drawingml/2006/main">
               <a:ext uri="{FF2B5EF4-FFF2-40B4-BE49-F238E27FC236}">
-                <a16:creationId xmlns:a16="http://schemas.microsoft.com/office/drawing/2014/main" id="{FF1D08CD-53BB-4A60-96E8-84B7211C855D}"/>
+                <a16:creationId xmlns:a16="http://schemas.microsoft.com/office/drawing/2014/main" id="{04A3B3B2-2E0B-4156-B41F-C17CF49518AB}"/>
               </a:ext>
             </a:extLst>
           </p:cNvPr>
@@ -11324,7 +11324,7 @@
           <p:cNvPr id="4" name="afterparty-p-3">
             <a:extLst xmlns:a="http://schemas.openxmlformats.org/drawingml/2006/main">
               <a:ext uri="{FF2B5EF4-FFF2-40B4-BE49-F238E27FC236}">
-                <a16:creationId xmlns:a16="http://schemas.microsoft.com/office/drawing/2014/main" id="{6230E446-7D9F-4DDF-AFDF-0D7E09410EB2}"/>
+                <a16:creationId xmlns:a16="http://schemas.microsoft.com/office/drawing/2014/main" id="{424B6472-9725-480B-9338-B97FB91A51A1}"/>
               </a:ext>
             </a:extLst>
           </p:cNvPr>
@@ -11392,7 +11392,7 @@
           <p:cNvPr id="5" name="afterparty-h1-4">
             <a:extLst xmlns:a="http://schemas.openxmlformats.org/drawingml/2006/main">
               <a:ext uri="{FF2B5EF4-FFF2-40B4-BE49-F238E27FC236}">
-                <a16:creationId xmlns:a16="http://schemas.microsoft.com/office/drawing/2014/main" id="{2352E466-BAA5-40E9-977E-2DE4534309EE}"/>
+                <a16:creationId xmlns:a16="http://schemas.microsoft.com/office/drawing/2014/main" id="{55F02A7A-7121-419C-BF8F-BD2312168F50}"/>
               </a:ext>
             </a:extLst>
           </p:cNvPr>
@@ -11460,7 +11460,7 @@
           <p:cNvPr id="6" name="afterparty-p-5">
             <a:extLst xmlns:a="http://schemas.openxmlformats.org/drawingml/2006/main">
               <a:ext uri="{FF2B5EF4-FFF2-40B4-BE49-F238E27FC236}">
-                <a16:creationId xmlns:a16="http://schemas.microsoft.com/office/drawing/2014/main" id="{CC09130A-96D1-4C7D-B59C-F391668C116E}"/>
+                <a16:creationId xmlns:a16="http://schemas.microsoft.com/office/drawing/2014/main" id="{A4E45E6D-B38D-4F81-BF79-9C531EBF6CC0}"/>
               </a:ext>
             </a:extLst>
           </p:cNvPr>
@@ -11528,7 +11528,7 @@
           <p:cNvPr id="7" name="afterparty-p-6">
             <a:extLst xmlns:a="http://schemas.openxmlformats.org/drawingml/2006/main">
               <a:ext uri="{FF2B5EF4-FFF2-40B4-BE49-F238E27FC236}">
-                <a16:creationId xmlns:a16="http://schemas.microsoft.com/office/drawing/2014/main" id="{B44A4A02-C4C3-443C-9B7C-77A5E3422C7B}"/>
+                <a16:creationId xmlns:a16="http://schemas.microsoft.com/office/drawing/2014/main" id="{EA134FCB-D0E9-465B-94F8-66397C3AFBA5}"/>
               </a:ext>
             </a:extLst>
           </p:cNvPr>
@@ -11596,7 +11596,7 @@
           <p:cNvPr id="8" name="afterparty-span-7">
             <a:extLst xmlns:a="http://schemas.openxmlformats.org/drawingml/2006/main">
               <a:ext uri="{FF2B5EF4-FFF2-40B4-BE49-F238E27FC236}">
-                <a16:creationId xmlns:a16="http://schemas.microsoft.com/office/drawing/2014/main" id="{49345D2F-4BC2-42D8-A743-D7B7E7416700}"/>
+                <a16:creationId xmlns:a16="http://schemas.microsoft.com/office/drawing/2014/main" id="{BF85A7C5-BAAA-4642-AF0C-CF77AA9B2816}"/>
               </a:ext>
             </a:extLst>
           </p:cNvPr>
@@ -11664,7 +11664,7 @@
           <p:cNvPr id="9" name="afterparty-span-8">
             <a:extLst xmlns:a="http://schemas.openxmlformats.org/drawingml/2006/main">
               <a:ext uri="{FF2B5EF4-FFF2-40B4-BE49-F238E27FC236}">
-                <a16:creationId xmlns:a16="http://schemas.microsoft.com/office/drawing/2014/main" id="{05394F52-DD2D-4AAF-8513-0705699528BD}"/>
+                <a16:creationId xmlns:a16="http://schemas.microsoft.com/office/drawing/2014/main" id="{9EBC656A-5A73-41D8-8EE4-A9A32F7CB3CA}"/>
               </a:ext>
             </a:extLst>
           </p:cNvPr>
@@ -11730,7 +11730,7 @@
     </p:spTree>
     <p:extLst>
       <p:ext uri="{BB962C8B-B14F-4D97-AF65-F5344CB8AC3E}">
-        <p14:creationId xmlns:p14="http://schemas.microsoft.com/office/powerpoint/2010/main" val="155073198"/>
+        <p14:creationId xmlns:p14="http://schemas.microsoft.com/office/powerpoint/2010/main" val="1705561901"/>
       </p:ext>
     </p:extLst>
   </p:cSld>
@@ -11761,7 +11761,7 @@
           <p:cNvPr id="12" name="">
             <a:extLst xmlns:a="http://schemas.openxmlformats.org/drawingml/2006/main">
               <a:ext uri="{FF2B5EF4-FFF2-40B4-BE49-F238E27FC236}">
-                <a16:creationId xmlns:a16="http://schemas.microsoft.com/office/drawing/2014/main" id="{7646C870-6BC7-42D3-A590-9B3CE1393276}"/>
+                <a16:creationId xmlns:a16="http://schemas.microsoft.com/office/drawing/2014/main" id="{FAFBD029-B05A-4124-9C82-8D6DF1CD4851}"/>
               </a:ext>
             </a:extLst>
           </p:cNvPr>
@@ -11771,7 +11771,7 @@
           <p:nvPr/>
         </p:nvPicPr>
         <p:blipFill>
-          <a:blip xmlns:r="http://schemas.openxmlformats.org/officeDocument/2006/relationships" xmlns:a="http://schemas.openxmlformats.org/drawingml/2006/main" r:embed="Rbd03440e35b94155"/>
+          <a:blip xmlns:r="http://schemas.openxmlformats.org/officeDocument/2006/relationships" xmlns:a="http://schemas.openxmlformats.org/drawingml/2006/main" r:embed="R559ae21e3a684ade"/>
           <a:stretch xmlns:a="http://schemas.openxmlformats.org/drawingml/2006/main"/>
         </p:blipFill>
         <p:spPr>
@@ -11789,7 +11789,7 @@
           <p:cNvPr id="2" name="hallway-track-span-1">
             <a:extLst xmlns:a="http://schemas.openxmlformats.org/drawingml/2006/main">
               <a:ext uri="{FF2B5EF4-FFF2-40B4-BE49-F238E27FC236}">
-                <a16:creationId xmlns:a16="http://schemas.microsoft.com/office/drawing/2014/main" id="{8051BAF2-02B1-4D0A-9EEC-115B8843134C}"/>
+                <a16:creationId xmlns:a16="http://schemas.microsoft.com/office/drawing/2014/main" id="{DA5E537D-754E-46F5-B624-88B7BD82ECE3}"/>
               </a:ext>
             </a:extLst>
           </p:cNvPr>
@@ -11857,7 +11857,7 @@
           <p:cNvPr id="3" name="hallway-track-span-2">
             <a:extLst xmlns:a="http://schemas.openxmlformats.org/drawingml/2006/main">
               <a:ext uri="{FF2B5EF4-FFF2-40B4-BE49-F238E27FC236}">
-                <a16:creationId xmlns:a16="http://schemas.microsoft.com/office/drawing/2014/main" id="{76B0074A-C33D-4F30-A802-771241656763}"/>
+                <a16:creationId xmlns:a16="http://schemas.microsoft.com/office/drawing/2014/main" id="{E2476524-B46E-4786-95D4-E654B64B4575}"/>
               </a:ext>
             </a:extLst>
           </p:cNvPr>
@@ -11925,7 +11925,7 @@
           <p:cNvPr id="4" name="hallway-track-h1-3">
             <a:extLst xmlns:a="http://schemas.openxmlformats.org/drawingml/2006/main">
               <a:ext uri="{FF2B5EF4-FFF2-40B4-BE49-F238E27FC236}">
-                <a16:creationId xmlns:a16="http://schemas.microsoft.com/office/drawing/2014/main" id="{8178584A-09D1-464D-B054-285FEEFA4829}"/>
+                <a16:creationId xmlns:a16="http://schemas.microsoft.com/office/drawing/2014/main" id="{8414B5D6-7630-438A-BB9A-B6C756949077}"/>
               </a:ext>
             </a:extLst>
           </p:cNvPr>
@@ -11993,7 +11993,7 @@
           <p:cNvPr id="5" name="hallway-track-h1-4">
             <a:extLst xmlns:a="http://schemas.openxmlformats.org/drawingml/2006/main">
               <a:ext uri="{FF2B5EF4-FFF2-40B4-BE49-F238E27FC236}">
-                <a16:creationId xmlns:a16="http://schemas.microsoft.com/office/drawing/2014/main" id="{D0881B9B-DEB9-4A4E-A1A9-7302872A50CF}"/>
+                <a16:creationId xmlns:a16="http://schemas.microsoft.com/office/drawing/2014/main" id="{AF7EC603-9789-4E2A-8DFE-452DF6E54EE7}"/>
               </a:ext>
             </a:extLst>
           </p:cNvPr>
@@ -12061,7 +12061,7 @@
           <p:cNvPr id="6" name="hallway-track-p-5">
             <a:extLst xmlns:a="http://schemas.openxmlformats.org/drawingml/2006/main">
               <a:ext uri="{FF2B5EF4-FFF2-40B4-BE49-F238E27FC236}">
-                <a16:creationId xmlns:a16="http://schemas.microsoft.com/office/drawing/2014/main" id="{B5B7F19B-EA4E-4F14-BE26-C95601BFC22D}"/>
+                <a16:creationId xmlns:a16="http://schemas.microsoft.com/office/drawing/2014/main" id="{DB4DAB89-E7ED-4349-ACC7-BD37E7325453}"/>
               </a:ext>
             </a:extLst>
           </p:cNvPr>
@@ -12129,7 +12129,7 @@
           <p:cNvPr id="7" name="hallway-track-p-6">
             <a:extLst xmlns:a="http://schemas.openxmlformats.org/drawingml/2006/main">
               <a:ext uri="{FF2B5EF4-FFF2-40B4-BE49-F238E27FC236}">
-                <a16:creationId xmlns:a16="http://schemas.microsoft.com/office/drawing/2014/main" id="{A0BF006C-390C-4494-A359-08C02D064001}"/>
+                <a16:creationId xmlns:a16="http://schemas.microsoft.com/office/drawing/2014/main" id="{0BDA5FB2-7FDB-448D-85E2-0442B4CD2B1C}"/>
               </a:ext>
             </a:extLst>
           </p:cNvPr>
@@ -12197,7 +12197,7 @@
           <p:cNvPr id="8" name="hallway-track-p-7">
             <a:extLst xmlns:a="http://schemas.openxmlformats.org/drawingml/2006/main">
               <a:ext uri="{FF2B5EF4-FFF2-40B4-BE49-F238E27FC236}">
-                <a16:creationId xmlns:a16="http://schemas.microsoft.com/office/drawing/2014/main" id="{EA6D4F5A-D13A-4CC6-BDFD-2832696C0896}"/>
+                <a16:creationId xmlns:a16="http://schemas.microsoft.com/office/drawing/2014/main" id="{346E3F6A-9C0F-4B1F-9DA7-34744541DAA6}"/>
               </a:ext>
             </a:extLst>
           </p:cNvPr>
@@ -12265,7 +12265,7 @@
           <p:cNvPr id="9" name="hallway-track-p-8">
             <a:extLst xmlns:a="http://schemas.openxmlformats.org/drawingml/2006/main">
               <a:ext uri="{FF2B5EF4-FFF2-40B4-BE49-F238E27FC236}">
-                <a16:creationId xmlns:a16="http://schemas.microsoft.com/office/drawing/2014/main" id="{15D7322E-F36A-48D9-BA68-64CFEC1B6D4B}"/>
+                <a16:creationId xmlns:a16="http://schemas.microsoft.com/office/drawing/2014/main" id="{939DB53C-6365-4DCC-9059-F9A81C3F1F28}"/>
               </a:ext>
             </a:extLst>
           </p:cNvPr>
@@ -12333,7 +12333,7 @@
           <p:cNvPr id="10" name="hallway-track-span-9">
             <a:extLst xmlns:a="http://schemas.openxmlformats.org/drawingml/2006/main">
               <a:ext uri="{FF2B5EF4-FFF2-40B4-BE49-F238E27FC236}">
-                <a16:creationId xmlns:a16="http://schemas.microsoft.com/office/drawing/2014/main" id="{115E3659-07DE-4276-9906-B4C9696616C9}"/>
+                <a16:creationId xmlns:a16="http://schemas.microsoft.com/office/drawing/2014/main" id="{A1D76FCD-11F0-4285-8E24-419821A8BC09}"/>
               </a:ext>
             </a:extLst>
           </p:cNvPr>
@@ -12401,7 +12401,7 @@
           <p:cNvPr id="11" name="hallway-track-span-10">
             <a:extLst xmlns:a="http://schemas.openxmlformats.org/drawingml/2006/main">
               <a:ext uri="{FF2B5EF4-FFF2-40B4-BE49-F238E27FC236}">
-                <a16:creationId xmlns:a16="http://schemas.microsoft.com/office/drawing/2014/main" id="{B695C407-44EB-4661-A172-11D88E43887F}"/>
+                <a16:creationId xmlns:a16="http://schemas.microsoft.com/office/drawing/2014/main" id="{37B31B48-C63B-429F-9A04-76982A568C8A}"/>
               </a:ext>
             </a:extLst>
           </p:cNvPr>
@@ -12467,7 +12467,7 @@
     </p:spTree>
     <p:extLst>
       <p:ext uri="{BB962C8B-B14F-4D97-AF65-F5344CB8AC3E}">
-        <p14:creationId xmlns:p14="http://schemas.microsoft.com/office/powerpoint/2010/main" val="79600721"/>
+        <p14:creationId xmlns:p14="http://schemas.microsoft.com/office/powerpoint/2010/main" val="1869787955"/>
       </p:ext>
     </p:extLst>
   </p:cSld>
@@ -12498,7 +12498,7 @@
           <p:cNvPr id="12" name="">
             <a:extLst xmlns:a="http://schemas.openxmlformats.org/drawingml/2006/main">
               <a:ext uri="{FF2B5EF4-FFF2-40B4-BE49-F238E27FC236}">
-                <a16:creationId xmlns:a16="http://schemas.microsoft.com/office/drawing/2014/main" id="{05AA9006-CAFE-420B-A392-A88D5B852BE7}"/>
+                <a16:creationId xmlns:a16="http://schemas.microsoft.com/office/drawing/2014/main" id="{DA0AF52E-6951-464F-A756-AB4BE9457DD1}"/>
               </a:ext>
             </a:extLst>
           </p:cNvPr>
@@ -12508,7 +12508,7 @@
           <p:nvPr/>
         </p:nvPicPr>
         <p:blipFill>
-          <a:blip xmlns:r="http://schemas.openxmlformats.org/officeDocument/2006/relationships" xmlns:a="http://schemas.openxmlformats.org/drawingml/2006/main" r:embed="R996ecaeeb833447b"/>
+          <a:blip xmlns:r="http://schemas.openxmlformats.org/officeDocument/2006/relationships" xmlns:a="http://schemas.openxmlformats.org/drawingml/2006/main" r:embed="Re8187b0034154805"/>
           <a:stretch xmlns:a="http://schemas.openxmlformats.org/drawingml/2006/main"/>
         </p:blipFill>
         <p:spPr>
@@ -12526,7 +12526,7 @@
           <p:cNvPr id="2" name="pacman-rule-span-1">
             <a:extLst xmlns:a="http://schemas.openxmlformats.org/drawingml/2006/main">
               <a:ext uri="{FF2B5EF4-FFF2-40B4-BE49-F238E27FC236}">
-                <a16:creationId xmlns:a16="http://schemas.microsoft.com/office/drawing/2014/main" id="{81D974E6-4C7B-4716-82CB-A9132031788A}"/>
+                <a16:creationId xmlns:a16="http://schemas.microsoft.com/office/drawing/2014/main" id="{471CF2D7-BDC7-4D6D-9611-E872C42C7231}"/>
               </a:ext>
             </a:extLst>
           </p:cNvPr>
@@ -12594,7 +12594,7 @@
           <p:cNvPr id="3" name="pacman-rule-span-2">
             <a:extLst xmlns:a="http://schemas.openxmlformats.org/drawingml/2006/main">
               <a:ext uri="{FF2B5EF4-FFF2-40B4-BE49-F238E27FC236}">
-                <a16:creationId xmlns:a16="http://schemas.microsoft.com/office/drawing/2014/main" id="{1C368EA5-2658-4E30-B1E3-F35B6DB5CEF6}"/>
+                <a16:creationId xmlns:a16="http://schemas.microsoft.com/office/drawing/2014/main" id="{DE82A88A-9527-42EC-BB30-7549C9C1CCA8}"/>
               </a:ext>
             </a:extLst>
           </p:cNvPr>
@@ -12662,7 +12662,7 @@
           <p:cNvPr id="4" name="pacman-rule-h1-3">
             <a:extLst xmlns:a="http://schemas.openxmlformats.org/drawingml/2006/main">
               <a:ext uri="{FF2B5EF4-FFF2-40B4-BE49-F238E27FC236}">
-                <a16:creationId xmlns:a16="http://schemas.microsoft.com/office/drawing/2014/main" id="{BDEDD143-8C31-4637-91E8-4CA3BBD6B39F}"/>
+                <a16:creationId xmlns:a16="http://schemas.microsoft.com/office/drawing/2014/main" id="{24B64589-5FBB-4FF0-A01B-BD168F9E1C17}"/>
               </a:ext>
             </a:extLst>
           </p:cNvPr>
@@ -12730,7 +12730,7 @@
           <p:cNvPr id="5" name="pacman-rule-h1-4">
             <a:extLst xmlns:a="http://schemas.openxmlformats.org/drawingml/2006/main">
               <a:ext uri="{FF2B5EF4-FFF2-40B4-BE49-F238E27FC236}">
-                <a16:creationId xmlns:a16="http://schemas.microsoft.com/office/drawing/2014/main" id="{533DD67D-A2F0-4FE7-9872-172F20C3F4C4}"/>
+                <a16:creationId xmlns:a16="http://schemas.microsoft.com/office/drawing/2014/main" id="{711E9F05-F693-49CD-B63C-AD25CC1DFE10}"/>
               </a:ext>
             </a:extLst>
           </p:cNvPr>
@@ -12798,7 +12798,7 @@
           <p:cNvPr id="6" name="pacman-rule-p-5">
             <a:extLst xmlns:a="http://schemas.openxmlformats.org/drawingml/2006/main">
               <a:ext uri="{FF2B5EF4-FFF2-40B4-BE49-F238E27FC236}">
-                <a16:creationId xmlns:a16="http://schemas.microsoft.com/office/drawing/2014/main" id="{FC6EF10F-2087-4D11-A7FD-A11420265461}"/>
+                <a16:creationId xmlns:a16="http://schemas.microsoft.com/office/drawing/2014/main" id="{B9D640CC-AA03-45CA-BF80-9586FE9CFA8E}"/>
               </a:ext>
             </a:extLst>
           </p:cNvPr>
@@ -12866,7 +12866,7 @@
           <p:cNvPr id="7" name="pacman-rule-p-6">
             <a:extLst xmlns:a="http://schemas.openxmlformats.org/drawingml/2006/main">
               <a:ext uri="{FF2B5EF4-FFF2-40B4-BE49-F238E27FC236}">
-                <a16:creationId xmlns:a16="http://schemas.microsoft.com/office/drawing/2014/main" id="{5700F659-A133-4B52-9095-B787851BC7B0}"/>
+                <a16:creationId xmlns:a16="http://schemas.microsoft.com/office/drawing/2014/main" id="{A8FB3A34-B06E-47E4-B17B-9D81190C4D65}"/>
               </a:ext>
             </a:extLst>
           </p:cNvPr>
@@ -12934,7 +12934,7 @@
           <p:cNvPr id="8" name="pacman-rule-p-7">
             <a:extLst xmlns:a="http://schemas.openxmlformats.org/drawingml/2006/main">
               <a:ext uri="{FF2B5EF4-FFF2-40B4-BE49-F238E27FC236}">
-                <a16:creationId xmlns:a16="http://schemas.microsoft.com/office/drawing/2014/main" id="{E34DA153-FA32-4F07-872F-3C97BF2B2399}"/>
+                <a16:creationId xmlns:a16="http://schemas.microsoft.com/office/drawing/2014/main" id="{FB6928FB-61DA-456C-80F1-A9F2875E8F54}"/>
               </a:ext>
             </a:extLst>
           </p:cNvPr>
@@ -13002,7 +13002,7 @@
           <p:cNvPr id="9" name="pacman-rule-p-8">
             <a:extLst xmlns:a="http://schemas.openxmlformats.org/drawingml/2006/main">
               <a:ext uri="{FF2B5EF4-FFF2-40B4-BE49-F238E27FC236}">
-                <a16:creationId xmlns:a16="http://schemas.microsoft.com/office/drawing/2014/main" id="{3BB95C88-4B33-4442-A1DF-4D0906146902}"/>
+                <a16:creationId xmlns:a16="http://schemas.microsoft.com/office/drawing/2014/main" id="{E0C6433E-19A8-493E-80E2-0DB54F5F3602}"/>
               </a:ext>
             </a:extLst>
           </p:cNvPr>
@@ -13070,7 +13070,7 @@
           <p:cNvPr id="10" name="pacman-rule-span-9">
             <a:extLst xmlns:a="http://schemas.openxmlformats.org/drawingml/2006/main">
               <a:ext uri="{FF2B5EF4-FFF2-40B4-BE49-F238E27FC236}">
-                <a16:creationId xmlns:a16="http://schemas.microsoft.com/office/drawing/2014/main" id="{1DF5DDB5-5A3A-4848-8E39-3EC024883206}"/>
+                <a16:creationId xmlns:a16="http://schemas.microsoft.com/office/drawing/2014/main" id="{7199EECF-4BE8-435E-BE40-FEC79DE40D16}"/>
               </a:ext>
             </a:extLst>
           </p:cNvPr>
@@ -13138,7 +13138,7 @@
           <p:cNvPr id="11" name="pacman-rule-span-10">
             <a:extLst xmlns:a="http://schemas.openxmlformats.org/drawingml/2006/main">
               <a:ext uri="{FF2B5EF4-FFF2-40B4-BE49-F238E27FC236}">
-                <a16:creationId xmlns:a16="http://schemas.microsoft.com/office/drawing/2014/main" id="{E4D5D7D1-7819-4996-B728-B4B3777BE9A4}"/>
+                <a16:creationId xmlns:a16="http://schemas.microsoft.com/office/drawing/2014/main" id="{97486330-D296-404F-8DCE-30FBDC79B545}"/>
               </a:ext>
             </a:extLst>
           </p:cNvPr>
@@ -13204,7 +13204,7 @@
     </p:spTree>
     <p:extLst>
       <p:ext uri="{BB962C8B-B14F-4D97-AF65-F5344CB8AC3E}">
-        <p14:creationId xmlns:p14="http://schemas.microsoft.com/office/powerpoint/2010/main" val="1244516750"/>
+        <p14:creationId xmlns:p14="http://schemas.microsoft.com/office/powerpoint/2010/main" val="938964601"/>
       </p:ext>
     </p:extLst>
   </p:cSld>
@@ -13235,7 +13235,7 @@
           <p:cNvPr id="11" name="">
             <a:extLst xmlns:a="http://schemas.openxmlformats.org/drawingml/2006/main">
               <a:ext uri="{FF2B5EF4-FFF2-40B4-BE49-F238E27FC236}">
-                <a16:creationId xmlns:a16="http://schemas.microsoft.com/office/drawing/2014/main" id="{95E5302E-EFC8-429D-B59F-8177CE913CCC}"/>
+                <a16:creationId xmlns:a16="http://schemas.microsoft.com/office/drawing/2014/main" id="{4A87C713-6A74-45E5-8066-96D6C415C52A}"/>
               </a:ext>
             </a:extLst>
           </p:cNvPr>
@@ -13245,7 +13245,7 @@
           <p:nvPr/>
         </p:nvPicPr>
         <p:blipFill>
-          <a:blip xmlns:r="http://schemas.openxmlformats.org/officeDocument/2006/relationships" xmlns:a="http://schemas.openxmlformats.org/drawingml/2006/main" r:embed="Rfdbabbd6edda4efb"/>
+          <a:blip xmlns:r="http://schemas.openxmlformats.org/officeDocument/2006/relationships" xmlns:a="http://schemas.openxmlformats.org/drawingml/2006/main" r:embed="Re1d5224c61204ef8"/>
           <a:stretch xmlns:a="http://schemas.openxmlformats.org/drawingml/2006/main"/>
         </p:blipFill>
         <p:spPr>
@@ -13263,7 +13263,7 @@
           <p:cNvPr id="2" name="">
             <a:extLst xmlns:a="http://schemas.openxmlformats.org/drawingml/2006/main">
               <a:ext uri="{FF2B5EF4-FFF2-40B4-BE49-F238E27FC236}">
-                <a16:creationId xmlns:a16="http://schemas.microsoft.com/office/drawing/2014/main" id="{617D71CA-4A83-452A-A9F7-148907023246}"/>
+                <a16:creationId xmlns:a16="http://schemas.microsoft.com/office/drawing/2014/main" id="{A7A8A937-9F96-49B0-8EE9-963A6D9672D4}"/>
               </a:ext>
             </a:extLst>
           </p:cNvPr>
@@ -13273,7 +13273,7 @@
           <p:nvPr/>
         </p:nvPicPr>
         <p:blipFill>
-          <a:blip xmlns:r="http://schemas.openxmlformats.org/officeDocument/2006/relationships" xmlns:a="http://schemas.openxmlformats.org/drawingml/2006/main" r:embed="Rc8760fa5e0464c5f"/>
+          <a:blip xmlns:r="http://schemas.openxmlformats.org/officeDocument/2006/relationships" xmlns:a="http://schemas.openxmlformats.org/drawingml/2006/main" r:embed="Ra39cdb812ed34582"/>
           <a:stretch xmlns:a="http://schemas.openxmlformats.org/drawingml/2006/main"/>
         </p:blipFill>
         <p:spPr>
@@ -13291,7 +13291,7 @@
           <p:cNvPr id="3" name="questions-span-1">
             <a:extLst xmlns:a="http://schemas.openxmlformats.org/drawingml/2006/main">
               <a:ext uri="{FF2B5EF4-FFF2-40B4-BE49-F238E27FC236}">
-                <a16:creationId xmlns:a16="http://schemas.microsoft.com/office/drawing/2014/main" id="{3D635EFB-E2DC-4CCF-B0BA-740646D8130F}"/>
+                <a16:creationId xmlns:a16="http://schemas.microsoft.com/office/drawing/2014/main" id="{7186E4D4-520C-46EE-BE64-172839D93FA1}"/>
               </a:ext>
             </a:extLst>
           </p:cNvPr>
@@ -13359,7 +13359,7 @@
           <p:cNvPr id="4" name="questions-span-2">
             <a:extLst xmlns:a="http://schemas.openxmlformats.org/drawingml/2006/main">
               <a:ext uri="{FF2B5EF4-FFF2-40B4-BE49-F238E27FC236}">
-                <a16:creationId xmlns:a16="http://schemas.microsoft.com/office/drawing/2014/main" id="{0A26FCE7-ECC8-4EE0-8F64-1E110055A655}"/>
+                <a16:creationId xmlns:a16="http://schemas.microsoft.com/office/drawing/2014/main" id="{1A1540B7-5047-4232-9105-1F5AAC5E8011}"/>
               </a:ext>
             </a:extLst>
           </p:cNvPr>
@@ -13427,7 +13427,7 @@
           <p:cNvPr id="5" name="questions-h1-3">
             <a:extLst xmlns:a="http://schemas.openxmlformats.org/drawingml/2006/main">
               <a:ext uri="{FF2B5EF4-FFF2-40B4-BE49-F238E27FC236}">
-                <a16:creationId xmlns:a16="http://schemas.microsoft.com/office/drawing/2014/main" id="{21D8F3B4-DE20-4BFB-8516-A32D880E056F}"/>
+                <a16:creationId xmlns:a16="http://schemas.microsoft.com/office/drawing/2014/main" id="{10E06AB6-A028-4D30-9985-83D6BEA7479A}"/>
               </a:ext>
             </a:extLst>
           </p:cNvPr>
@@ -13495,7 +13495,7 @@
           <p:cNvPr id="6" name="questions-p-4">
             <a:extLst xmlns:a="http://schemas.openxmlformats.org/drawingml/2006/main">
               <a:ext uri="{FF2B5EF4-FFF2-40B4-BE49-F238E27FC236}">
-                <a16:creationId xmlns:a16="http://schemas.microsoft.com/office/drawing/2014/main" id="{3C541A0B-F9B6-469D-9A44-C3A32AFB7ED5}"/>
+                <a16:creationId xmlns:a16="http://schemas.microsoft.com/office/drawing/2014/main" id="{FEEE3828-943F-41C0-BE5F-3B4377D0BB4E}"/>
               </a:ext>
             </a:extLst>
           </p:cNvPr>
@@ -13563,7 +13563,7 @@
           <p:cNvPr id="7" name="questions-p-5">
             <a:extLst xmlns:a="http://schemas.openxmlformats.org/drawingml/2006/main">
               <a:ext uri="{FF2B5EF4-FFF2-40B4-BE49-F238E27FC236}">
-                <a16:creationId xmlns:a16="http://schemas.microsoft.com/office/drawing/2014/main" id="{5BD63278-2AA8-40E0-81D3-5B8005BC1937}"/>
+                <a16:creationId xmlns:a16="http://schemas.microsoft.com/office/drawing/2014/main" id="{739F58A6-7409-4FBA-B573-E399FAD130BE}"/>
               </a:ext>
             </a:extLst>
           </p:cNvPr>
@@ -13631,7 +13631,7 @@
           <p:cNvPr id="8" name="questions-a-6">
             <a:extLst xmlns:a="http://schemas.openxmlformats.org/drawingml/2006/main">
               <a:ext uri="{FF2B5EF4-FFF2-40B4-BE49-F238E27FC236}">
-                <a16:creationId xmlns:a16="http://schemas.microsoft.com/office/drawing/2014/main" id="{3310280C-68B9-4BDF-A416-1845047A5A3D}"/>
+                <a16:creationId xmlns:a16="http://schemas.microsoft.com/office/drawing/2014/main" id="{C00024DD-863C-45F1-87EA-AD298FA15399}"/>
               </a:ext>
             </a:extLst>
           </p:cNvPr>
@@ -13688,7 +13688,7 @@
                 <a:latin typeface="Finlandica Headline"/>
                 <a:ea typeface="Finlandica Headline"/>
                 <a:cs typeface="Finlandica Headline"/>
-                <a:hlinkClick xmlns:r="http://schemas.openxmlformats.org/officeDocument/2006/relationships" r:id="Re873357e9b404b49"/>
+                <a:hlinkClick xmlns:r="http://schemas.openxmlformats.org/officeDocument/2006/relationships" r:id="R36a22c184506494d"/>
               </a:rPr>
               <a:t>sdlcai.org/qa</a:t>
             </a:r>
@@ -13700,7 +13700,7 @@
           <p:cNvPr id="9" name="questions-span-7">
             <a:extLst xmlns:a="http://schemas.openxmlformats.org/drawingml/2006/main">
               <a:ext uri="{FF2B5EF4-FFF2-40B4-BE49-F238E27FC236}">
-                <a16:creationId xmlns:a16="http://schemas.microsoft.com/office/drawing/2014/main" id="{27983BE4-082C-4155-B6CD-0B0A0A93024D}"/>
+                <a16:creationId xmlns:a16="http://schemas.microsoft.com/office/drawing/2014/main" id="{361EC88C-88EC-4B23-85AE-389D206FEA48}"/>
               </a:ext>
             </a:extLst>
           </p:cNvPr>
@@ -13768,7 +13768,7 @@
           <p:cNvPr id="10" name="questions-span-8">
             <a:extLst xmlns:a="http://schemas.openxmlformats.org/drawingml/2006/main">
               <a:ext uri="{FF2B5EF4-FFF2-40B4-BE49-F238E27FC236}">
-                <a16:creationId xmlns:a16="http://schemas.microsoft.com/office/drawing/2014/main" id="{82501DCD-DDA6-49F8-8AC3-72E6D762DE23}"/>
+                <a16:creationId xmlns:a16="http://schemas.microsoft.com/office/drawing/2014/main" id="{6DE66C66-2593-4AE2-9B88-695375E00B2B}"/>
               </a:ext>
             </a:extLst>
           </p:cNvPr>
@@ -13834,7 +13834,7 @@
     </p:spTree>
     <p:extLst>
       <p:ext uri="{BB962C8B-B14F-4D97-AF65-F5344CB8AC3E}">
-        <p14:creationId xmlns:p14="http://schemas.microsoft.com/office/powerpoint/2010/main" val="1236386317"/>
+        <p14:creationId xmlns:p14="http://schemas.microsoft.com/office/powerpoint/2010/main" val="1197943615"/>
       </p:ext>
     </p:extLst>
   </p:cSld>

</xml_diff>